<commit_message>
Add OpenVLA-style VERA architecture diagram (v6)
- White background, left-to-right flow, dashed VERA model border
- Individual coloured token blocks per stream
- Vertical merge-bar replaces fan of crossing diagonal arrows
- Numbered step badges ①②③④
- Rename E=Experience → E=Embodied Knowledge throughout diagram
- Correct 6 fusion layers, CLIP ViT trainable (green), CLIP Text frozen (dashed)
- Output panel now fits inside figure canvas (OUTX fixed)
- Generates both VERA.png (200 dpi) and VERA_architecture.pptx (16×9)

Co-Authored-By: Claude Sonnet 4.6 <noreply@anthropic.com>
</commit_message>
<xml_diff>
--- a/docs/VERA_architecture.pptx
+++ b/docs/VERA_architecture.pptx
@@ -3103,7 +3103,7 @@
             <a:avLst/>
           </a:prstGeom>
           <a:solidFill>
-            <a:srgbClr val="F4F6FB"/>
+            <a:srgbClr val="FFFFFF"/>
           </a:solidFill>
           <a:ln>
             <a:noFill/>
@@ -3139,8 +3139,8 @@
         </p:nvSpPr>
         <p:spPr>
           <a:xfrm>
-            <a:off x="201168" y="36576"/>
-            <a:ext cx="14228064" cy="402336"/>
+            <a:off x="99752" y="39188"/>
+            <a:ext cx="14430894" cy="391885"/>
           </a:xfrm>
           <a:prstGeom prst="rect">
             <a:avLst/>
@@ -3155,26 +3155,74 @@
           <a:p>
             <a:pPr algn="ctr"/>
             <a:r>
-              <a:rPr sz="2000" b="1">
-                <a:solidFill>
-                  <a:srgbClr val="1C1C1C"/>
+              <a:rPr sz="1600" b="1">
+                <a:solidFill>
+                  <a:srgbClr val="212121"/>
                 </a:solidFill>
               </a:rPr>
-              <a:t>VERA  —  Vision · Experience · Reasoning · Action</a:t>
-            </a:r>
-          </a:p>
-        </p:txBody>
-      </p:sp>
-      <p:sp>
-        <p:nvSpPr>
-          <p:cNvPr id="4" name="TextBox 3"/>
+              <a:t>VERA: Vision · Embodied Knowledge · Reasoning · Action</a:t>
+            </a:r>
+          </a:p>
+        </p:txBody>
+      </p:sp>
+      <p:sp>
+        <p:nvSpPr>
+          <p:cNvPr id="4" name="Rounded Rectangle 3"/>
+          <p:cNvSpPr/>
+          <p:nvPr/>
+        </p:nvSpPr>
+        <p:spPr>
+          <a:xfrm>
+            <a:off x="2241111" y="391885"/>
+            <a:ext cx="10759994" cy="7406640"/>
+          </a:xfrm>
+          <a:prstGeom prst="roundRect">
+            <a:avLst>
+              <a:gd name="adj" fmla="val 4000"/>
+            </a:avLst>
+          </a:prstGeom>
+          <a:solidFill>
+            <a:srgbClr val="FAFAFA"/>
+          </a:solidFill>
+          <a:ln w="25400">
+            <a:solidFill>
+              <a:srgbClr val="455A64"/>
+            </a:solidFill>
+            <a:prstDash val="dash"/>
+          </a:ln>
+        </p:spPr>
+        <p:style>
+          <a:lnRef idx="1">
+            <a:schemeClr val="accent1"/>
+          </a:lnRef>
+          <a:fillRef idx="3">
+            <a:schemeClr val="accent1"/>
+          </a:fillRef>
+          <a:effectRef idx="2">
+            <a:schemeClr val="accent1"/>
+          </a:effectRef>
+          <a:fontRef idx="minor">
+            <a:schemeClr val="lt1"/>
+          </a:fontRef>
+        </p:style>
+        <p:txBody>
+          <a:bodyPr rtlCol="0" anchor="ctr" wrap="none"/>
+          <a:lstStyle/>
+          <a:p>
+            <a:pPr algn="ctr"/>
+          </a:p>
+        </p:txBody>
+      </p:sp>
+      <p:sp>
+        <p:nvSpPr>
+          <p:cNvPr id="5" name="TextBox 4"/>
           <p:cNvSpPr txBox="1"/>
           <p:nvPr/>
         </p:nvSpPr>
         <p:spPr>
           <a:xfrm>
-            <a:off x="201168" y="402336"/>
-            <a:ext cx="14228064" cy="256032"/>
+            <a:off x="2507118" y="423236"/>
+            <a:ext cx="1197032" cy="297833"/>
           </a:xfrm>
           <a:prstGeom prst="rect">
             <a:avLst/>
@@ -3187,28 +3235,28 @@
           </a:bodyPr>
           <a:lstStyle/>
           <a:p>
-            <a:pPr algn="ctr"/>
-            <a:r>
-              <a:rPr sz="950" b="0">
-                <a:solidFill>
-                  <a:srgbClr val="555555"/>
+            <a:pPr algn="l"/>
+            <a:r>
+              <a:rPr sz="1100" b="1">
+                <a:solidFill>
+                  <a:srgbClr val="212121"/>
                 </a:solidFill>
               </a:rPr>
-              <a:t>5-stream closed-loop robot policy   ·   6-layer Bidirectional LLaMA Fusion Transformer   ·   K = 4 action chunking   ·   λ_align = 0.10</a:t>
-            </a:r>
-          </a:p>
-        </p:txBody>
-      </p:sp>
-      <p:sp>
-        <p:nvSpPr>
-          <p:cNvPr id="5" name="Rounded Rectangle 4"/>
+              <a:t>VERA</a:t>
+            </a:r>
+          </a:p>
+        </p:txBody>
+      </p:sp>
+      <p:sp>
+        <p:nvSpPr>
+          <p:cNvPr id="6" name="Rounded Rectangle 5"/>
           <p:cNvSpPr/>
           <p:nvPr/>
         </p:nvSpPr>
         <p:spPr>
           <a:xfrm>
-            <a:off x="201168" y="6940296"/>
-            <a:ext cx="1920239" cy="914400"/>
+            <a:off x="99752" y="920931"/>
+            <a:ext cx="1808849" cy="822960"/>
           </a:xfrm>
           <a:prstGeom prst="roundRect">
             <a:avLst>
@@ -3242,37 +3290,37 @@
           <a:p>
             <a:pPr algn="ctr"/>
             <a:r>
-              <a:rPr sz="1100" b="1">
+              <a:rPr sz="900" b="1">
                 <a:solidFill>
                   <a:srgbClr val="FFFFFF"/>
                 </a:solidFill>
               </a:rPr>
-              <a:t>3 RGB Frames</a:t>
+              <a:t>Vision</a:t>
             </a:r>
           </a:p>
           <a:p>
             <a:pPr algn="ctr"/>
             <a:r>
-              <a:rPr sz="900" b="0">
+              <a:rPr sz="800" b="0">
                 <a:solidFill>
                   <a:srgbClr val="FFFFFF"/>
                 </a:solidFill>
               </a:rPr>
-              <a:t>224 × 224 × 3</a:t>
-            </a:r>
-          </a:p>
-        </p:txBody>
-      </p:sp>
-      <p:sp>
-        <p:nvSpPr>
-          <p:cNvPr id="6" name="Rounded Rectangle 5"/>
+              <a:t>3 RGB Frames · 224×224×3</a:t>
+            </a:r>
+          </a:p>
+        </p:txBody>
+      </p:sp>
+      <p:sp>
+        <p:nvSpPr>
+          <p:cNvPr id="7" name="Rounded Rectangle 6"/>
           <p:cNvSpPr/>
           <p:nvPr/>
         </p:nvSpPr>
         <p:spPr>
           <a:xfrm>
-            <a:off x="2267712" y="6940296"/>
-            <a:ext cx="1920239" cy="914400"/>
+            <a:off x="99752" y="2135777"/>
+            <a:ext cx="1808849" cy="822960"/>
           </a:xfrm>
           <a:prstGeom prst="roundRect">
             <a:avLst>
@@ -3306,12 +3354,12 @@
           <a:p>
             <a:pPr algn="ctr"/>
             <a:r>
-              <a:rPr sz="1100" b="1">
+              <a:rPr sz="900" b="1">
                 <a:solidFill>
                   <a:srgbClr val="FFFFFF"/>
                 </a:solidFill>
               </a:rPr>
-              <a:t>Task Instruction</a:t>
+              <a:t>Instruction</a:t>
             </a:r>
           </a:p>
           <a:p>
@@ -3329,14 +3377,14 @@
       </p:sp>
       <p:sp>
         <p:nvSpPr>
-          <p:cNvPr id="7" name="Rounded Rectangle 6"/>
+          <p:cNvPr id="8" name="Rounded Rectangle 7"/>
           <p:cNvSpPr/>
           <p:nvPr/>
         </p:nvSpPr>
         <p:spPr>
           <a:xfrm>
-            <a:off x="4334255" y="6940296"/>
-            <a:ext cx="1920239" cy="914400"/>
+            <a:off x="99752" y="3350622"/>
+            <a:ext cx="1808849" cy="822960"/>
           </a:xfrm>
           <a:prstGeom prst="roundRect">
             <a:avLst>
@@ -3370,12 +3418,12 @@
           <a:p>
             <a:pPr algn="ctr"/>
             <a:r>
-              <a:rPr sz="1000" b="1">
+              <a:rPr sz="900" b="1">
                 <a:solidFill>
                   <a:srgbClr val="FFFFFF"/>
                 </a:solidFill>
               </a:rPr>
-              <a:t>Prior Action  a_{t−1}</a:t>
+              <a:t>Action Narration</a:t>
             </a:r>
           </a:p>
           <a:p>
@@ -3386,21 +3434,21 @@
                   <a:srgbClr val="FFFFFF"/>
                 </a:solidFill>
               </a:rPr>
-              <a:t>discrete bin [0–7]</a:t>
-            </a:r>
-          </a:p>
-        </p:txBody>
-      </p:sp>
-      <p:sp>
-        <p:nvSpPr>
-          <p:cNvPr id="8" name="Rounded Rectangle 7"/>
+              <a:t>a_{t−1} text narration</a:t>
+            </a:r>
+          </a:p>
+        </p:txBody>
+      </p:sp>
+      <p:sp>
+        <p:nvSpPr>
+          <p:cNvPr id="9" name="Rounded Rectangle 8"/>
           <p:cNvSpPr/>
           <p:nvPr/>
         </p:nvSpPr>
         <p:spPr>
           <a:xfrm>
-            <a:off x="6400799" y="6940296"/>
-            <a:ext cx="1920239" cy="914400"/>
+            <a:off x="99752" y="4565468"/>
+            <a:ext cx="1808849" cy="822960"/>
           </a:xfrm>
           <a:prstGeom prst="roundRect">
             <a:avLst>
@@ -3408,7 +3456,7 @@
             </a:avLst>
           </a:prstGeom>
           <a:solidFill>
-            <a:srgbClr val="AD1457"/>
+            <a:srgbClr val="880E4F"/>
           </a:solidFill>
           <a:ln>
             <a:noFill/>
@@ -3434,12 +3482,12 @@
           <a:p>
             <a:pPr algn="ctr"/>
             <a:r>
-              <a:rPr sz="1000" b="1">
+              <a:rPr sz="900" b="1">
                 <a:solidFill>
                   <a:srgbClr val="FFFFFF"/>
                 </a:solidFill>
               </a:rPr>
-              <a:t>r_{t−1}  ·  Δd_{t−1}</a:t>
+              <a:t>Embodied Knowledge</a:t>
             </a:r>
           </a:p>
           <a:p>
@@ -3450,71 +3498,7 @@
                   <a:srgbClr val="FFFFFF"/>
                 </a:solidFill>
               </a:rPr>
-              <a:t>reward + state delta</a:t>
-            </a:r>
-          </a:p>
-        </p:txBody>
-      </p:sp>
-      <p:sp>
-        <p:nvSpPr>
-          <p:cNvPr id="9" name="Rounded Rectangle 8"/>
-          <p:cNvSpPr/>
-          <p:nvPr/>
-        </p:nvSpPr>
-        <p:spPr>
-          <a:xfrm>
-            <a:off x="8467344" y="6940296"/>
-            <a:ext cx="1920239" cy="914400"/>
-          </a:xfrm>
-          <a:prstGeom prst="roundRect">
-            <a:avLst>
-              <a:gd name="adj" fmla="val 4000"/>
-            </a:avLst>
-          </a:prstGeom>
-          <a:solidFill>
-            <a:srgbClr val="6A1B9A"/>
-          </a:solidFill>
-          <a:ln>
-            <a:noFill/>
-          </a:ln>
-        </p:spPr>
-        <p:style>
-          <a:lnRef idx="1">
-            <a:schemeClr val="accent1"/>
-          </a:lnRef>
-          <a:fillRef idx="3">
-            <a:schemeClr val="accent1"/>
-          </a:fillRef>
-          <a:effectRef idx="2">
-            <a:schemeClr val="accent1"/>
-          </a:effectRef>
-          <a:fontRef idx="minor">
-            <a:schemeClr val="lt1"/>
-          </a:fontRef>
-        </p:style>
-        <p:txBody>
-          <a:bodyPr rtlCol="0" anchor="ctr" wrap="none"/>
-          <a:lstStyle/>
-          <a:p>
-            <a:pPr algn="ctr"/>
-            <a:r>
-              <a:rPr sz="1000" b="1">
-                <a:solidFill>
-                  <a:srgbClr val="FFFFFF"/>
-                </a:solidFill>
-              </a:rPr>
-              <a:t>History Window</a:t>
-            </a:r>
-          </a:p>
-          <a:p>
-            <a:pPr algn="ctr"/>
-            <a:r>
-              <a:rPr sz="800" b="0">
-                <a:solidFill>
-                  <a:srgbClr val="FFFFFF"/>
-                </a:solidFill>
-              </a:rPr>
-              <a:t>H = 4  (action, reward) pairs</a:t>
+              <a:t>r_{t−1} · Δd_{t−1}</a:t>
             </a:r>
           </a:p>
         </p:txBody>
@@ -3527,643 +3511,8 @@
         </p:nvSpPr>
         <p:spPr>
           <a:xfrm>
-            <a:off x="7772399" y="6995159"/>
-            <a:ext cx="502920" cy="237744"/>
-          </a:xfrm>
-          <a:prstGeom prst="roundRect">
-            <a:avLst>
-              <a:gd name="adj" fmla="val 4000"/>
-            </a:avLst>
-          </a:prstGeom>
-          <a:solidFill>
-            <a:srgbClr val="B71C1C"/>
-          </a:solidFill>
-          <a:ln>
-            <a:noFill/>
-          </a:ln>
-        </p:spPr>
-        <p:style>
-          <a:lnRef idx="1">
-            <a:schemeClr val="accent1"/>
-          </a:lnRef>
-          <a:fillRef idx="3">
-            <a:schemeClr val="accent1"/>
-          </a:fillRef>
-          <a:effectRef idx="2">
-            <a:schemeClr val="accent1"/>
-          </a:effectRef>
-          <a:fontRef idx="minor">
-            <a:schemeClr val="lt1"/>
-          </a:fontRef>
-        </p:style>
-        <p:txBody>
-          <a:bodyPr rtlCol="0" anchor="ctr" wrap="none"/>
-          <a:lstStyle/>
-          <a:p>
-            <a:pPr algn="ctr"/>
-            <a:r>
-              <a:rPr sz="800" b="1">
-                <a:solidFill>
-                  <a:srgbClr val="FFFFFF"/>
-                </a:solidFill>
-              </a:rPr>
-              <a:t>NEW</a:t>
-            </a:r>
-          </a:p>
-        </p:txBody>
-      </p:sp>
-      <p:cxnSp>
-        <p:nvCxnSpPr>
-          <p:cNvPr id="11" name="Connector 10"/>
-          <p:cNvCxnSpPr/>
-          <p:nvPr/>
-        </p:nvCxnSpPr>
-        <p:spPr>
-          <a:xfrm flipV="1">
-            <a:off x="1161287" y="6757416"/>
-            <a:ext cx="0" cy="182880"/>
-          </a:xfrm>
-          <a:prstGeom prst="line">
-            <a:avLst/>
-          </a:prstGeom>
-          <a:ln w="22860">
-            <a:solidFill>
-              <a:srgbClr val="555555"/>
-            </a:solidFill>
-            <a:tailEnd type="none"/>
-            <a:headEnd type="arrow" w="med" len="med"/>
-          </a:ln>
-        </p:spPr>
-        <p:style>
-          <a:lnRef idx="2">
-            <a:schemeClr val="accent1"/>
-          </a:lnRef>
-          <a:fillRef idx="0">
-            <a:schemeClr val="accent1"/>
-          </a:fillRef>
-          <a:effectRef idx="1">
-            <a:schemeClr val="accent1"/>
-          </a:effectRef>
-          <a:fontRef idx="minor">
-            <a:schemeClr val="tx1"/>
-          </a:fontRef>
-        </p:style>
-      </p:cxnSp>
-      <p:cxnSp>
-        <p:nvCxnSpPr>
-          <p:cNvPr id="12" name="Connector 11"/>
-          <p:cNvCxnSpPr/>
-          <p:nvPr/>
-        </p:nvCxnSpPr>
-        <p:spPr>
-          <a:xfrm flipV="1">
-            <a:off x="3227832" y="6757416"/>
-            <a:ext cx="0" cy="182880"/>
-          </a:xfrm>
-          <a:prstGeom prst="line">
-            <a:avLst/>
-          </a:prstGeom>
-          <a:ln w="22860">
-            <a:solidFill>
-              <a:srgbClr val="555555"/>
-            </a:solidFill>
-            <a:tailEnd type="none"/>
-            <a:headEnd type="arrow" w="med" len="med"/>
-          </a:ln>
-        </p:spPr>
-        <p:style>
-          <a:lnRef idx="2">
-            <a:schemeClr val="accent1"/>
-          </a:lnRef>
-          <a:fillRef idx="0">
-            <a:schemeClr val="accent1"/>
-          </a:fillRef>
-          <a:effectRef idx="1">
-            <a:schemeClr val="accent1"/>
-          </a:effectRef>
-          <a:fontRef idx="minor">
-            <a:schemeClr val="tx1"/>
-          </a:fontRef>
-        </p:style>
-      </p:cxnSp>
-      <p:cxnSp>
-        <p:nvCxnSpPr>
-          <p:cNvPr id="13" name="Connector 12"/>
-          <p:cNvCxnSpPr/>
-          <p:nvPr/>
-        </p:nvCxnSpPr>
-        <p:spPr>
-          <a:xfrm flipV="1">
-            <a:off x="5294375" y="6757416"/>
-            <a:ext cx="0" cy="182880"/>
-          </a:xfrm>
-          <a:prstGeom prst="line">
-            <a:avLst/>
-          </a:prstGeom>
-          <a:ln w="22860">
-            <a:solidFill>
-              <a:srgbClr val="555555"/>
-            </a:solidFill>
-            <a:tailEnd type="none"/>
-            <a:headEnd type="arrow" w="med" len="med"/>
-          </a:ln>
-        </p:spPr>
-        <p:style>
-          <a:lnRef idx="2">
-            <a:schemeClr val="accent1"/>
-          </a:lnRef>
-          <a:fillRef idx="0">
-            <a:schemeClr val="accent1"/>
-          </a:fillRef>
-          <a:effectRef idx="1">
-            <a:schemeClr val="accent1"/>
-          </a:effectRef>
-          <a:fontRef idx="minor">
-            <a:schemeClr val="tx1"/>
-          </a:fontRef>
-        </p:style>
-      </p:cxnSp>
-      <p:cxnSp>
-        <p:nvCxnSpPr>
-          <p:cNvPr id="14" name="Connector 13"/>
-          <p:cNvCxnSpPr/>
-          <p:nvPr/>
-        </p:nvCxnSpPr>
-        <p:spPr>
-          <a:xfrm flipV="1">
-            <a:off x="7360919" y="6757416"/>
-            <a:ext cx="0" cy="182880"/>
-          </a:xfrm>
-          <a:prstGeom prst="line">
-            <a:avLst/>
-          </a:prstGeom>
-          <a:ln w="22860">
-            <a:solidFill>
-              <a:srgbClr val="555555"/>
-            </a:solidFill>
-            <a:tailEnd type="none"/>
-            <a:headEnd type="arrow" w="med" len="med"/>
-          </a:ln>
-        </p:spPr>
-        <p:style>
-          <a:lnRef idx="2">
-            <a:schemeClr val="accent1"/>
-          </a:lnRef>
-          <a:fillRef idx="0">
-            <a:schemeClr val="accent1"/>
-          </a:fillRef>
-          <a:effectRef idx="1">
-            <a:schemeClr val="accent1"/>
-          </a:effectRef>
-          <a:fontRef idx="minor">
-            <a:schemeClr val="tx1"/>
-          </a:fontRef>
-        </p:style>
-      </p:cxnSp>
-      <p:cxnSp>
-        <p:nvCxnSpPr>
-          <p:cNvPr id="15" name="Connector 14"/>
-          <p:cNvCxnSpPr/>
-          <p:nvPr/>
-        </p:nvCxnSpPr>
-        <p:spPr>
-          <a:xfrm flipV="1">
-            <a:off x="9427463" y="6757416"/>
-            <a:ext cx="0" cy="182880"/>
-          </a:xfrm>
-          <a:prstGeom prst="line">
-            <a:avLst/>
-          </a:prstGeom>
-          <a:ln w="22860">
-            <a:solidFill>
-              <a:srgbClr val="555555"/>
-            </a:solidFill>
-            <a:tailEnd type="none"/>
-            <a:headEnd type="arrow" w="med" len="med"/>
-          </a:ln>
-        </p:spPr>
-        <p:style>
-          <a:lnRef idx="2">
-            <a:schemeClr val="accent1"/>
-          </a:lnRef>
-          <a:fillRef idx="0">
-            <a:schemeClr val="accent1"/>
-          </a:fillRef>
-          <a:effectRef idx="1">
-            <a:schemeClr val="accent1"/>
-          </a:effectRef>
-          <a:fontRef idx="minor">
-            <a:schemeClr val="tx1"/>
-          </a:fontRef>
-        </p:style>
-      </p:cxnSp>
-      <p:sp>
-        <p:nvSpPr>
-          <p:cNvPr id="16" name="Rounded Rectangle 15"/>
-          <p:cNvSpPr/>
-          <p:nvPr/>
-        </p:nvSpPr>
-        <p:spPr>
-          <a:xfrm>
-            <a:off x="201168" y="5769864"/>
-            <a:ext cx="1920239" cy="987552"/>
-          </a:xfrm>
-          <a:prstGeom prst="roundRect">
-            <a:avLst>
-              <a:gd name="adj" fmla="val 4000"/>
-            </a:avLst>
-          </a:prstGeom>
-          <a:solidFill>
-            <a:srgbClr val="1565C0"/>
-          </a:solidFill>
-          <a:ln w="38100">
-            <a:solidFill>
-              <a:srgbClr val="A5D6A7"/>
-            </a:solidFill>
-          </a:ln>
-        </p:spPr>
-        <p:style>
-          <a:lnRef idx="1">
-            <a:schemeClr val="accent1"/>
-          </a:lnRef>
-          <a:fillRef idx="3">
-            <a:schemeClr val="accent1"/>
-          </a:fillRef>
-          <a:effectRef idx="2">
-            <a:schemeClr val="accent1"/>
-          </a:effectRef>
-          <a:fontRef idx="minor">
-            <a:schemeClr val="lt1"/>
-          </a:fontRef>
-        </p:style>
-        <p:txBody>
-          <a:bodyPr rtlCol="0" anchor="ctr" wrap="none"/>
-          <a:lstStyle/>
-          <a:p>
-            <a:pPr algn="ctr"/>
-            <a:r>
-              <a:rPr sz="1100" b="1">
-                <a:solidFill>
-                  <a:srgbClr val="FFFFFF"/>
-                </a:solidFill>
-              </a:rPr>
-              <a:t>CLIP ViT-B/32</a:t>
-            </a:r>
-          </a:p>
-          <a:p>
-            <a:pPr algn="ctr"/>
-            <a:r>
-              <a:rPr sz="900" b="1">
-                <a:solidFill>
-                  <a:srgbClr val="FFFFFF"/>
-                </a:solidFill>
-              </a:rPr>
-              <a:t>✓  fine-tuned</a:t>
-            </a:r>
-          </a:p>
-          <a:p>
-            <a:pPr algn="ctr"/>
-            <a:r>
-              <a:rPr sz="850" b="0">
-                <a:solidFill>
-                  <a:srgbClr val="FFFFFF"/>
-                </a:solidFill>
-              </a:rPr>
-              <a:t>lr = 3e-6</a:t>
-            </a:r>
-          </a:p>
-          <a:p>
-            <a:pPr algn="ctr"/>
-            <a:r>
-              <a:rPr sz="800" b="0">
-                <a:solidFill>
-                  <a:srgbClr val="FFFFFF"/>
-                </a:solidFill>
-              </a:rPr>
-              <a:t>→ 197 patch tokens</a:t>
-            </a:r>
-          </a:p>
-        </p:txBody>
-      </p:sp>
-      <p:sp>
-        <p:nvSpPr>
-          <p:cNvPr id="17" name="Rounded Rectangle 16"/>
-          <p:cNvSpPr/>
-          <p:nvPr/>
-        </p:nvSpPr>
-        <p:spPr>
-          <a:xfrm>
-            <a:off x="2267712" y="5769864"/>
-            <a:ext cx="1920239" cy="987552"/>
-          </a:xfrm>
-          <a:prstGeom prst="roundRect">
-            <a:avLst>
-              <a:gd name="adj" fmla="val 4000"/>
-            </a:avLst>
-          </a:prstGeom>
-          <a:solidFill>
-            <a:srgbClr val="37474F"/>
-          </a:solidFill>
-          <a:ln w="38100">
-            <a:solidFill>
-              <a:srgbClr val="80DEEA"/>
-            </a:solidFill>
-            <a:prstDash val="dash"/>
-          </a:ln>
-        </p:spPr>
-        <p:style>
-          <a:lnRef idx="1">
-            <a:schemeClr val="accent1"/>
-          </a:lnRef>
-          <a:fillRef idx="3">
-            <a:schemeClr val="accent1"/>
-          </a:fillRef>
-          <a:effectRef idx="2">
-            <a:schemeClr val="accent1"/>
-          </a:effectRef>
-          <a:fontRef idx="minor">
-            <a:schemeClr val="lt1"/>
-          </a:fontRef>
-        </p:style>
-        <p:txBody>
-          <a:bodyPr rtlCol="0" anchor="ctr" wrap="none"/>
-          <a:lstStyle/>
-          <a:p>
-            <a:pPr algn="ctr"/>
-            <a:r>
-              <a:rPr sz="1100" b="1">
-                <a:solidFill>
-                  <a:srgbClr val="FFFFFF"/>
-                </a:solidFill>
-              </a:rPr>
-              <a:t>CLIP Text Encoder</a:t>
-            </a:r>
-          </a:p>
-          <a:p>
-            <a:pPr algn="ctr"/>
-            <a:r>
-              <a:rPr sz="1000" b="1">
-                <a:solidFill>
-                  <a:srgbClr val="FFFFFF"/>
-                </a:solidFill>
-              </a:rPr>
-              <a:t>❄  FROZEN</a:t>
-            </a:r>
-          </a:p>
-          <a:p>
-            <a:pPr algn="ctr"/>
-            <a:r>
-              <a:rPr sz="800" b="0">
-                <a:solidFill>
-                  <a:srgbClr val="FFFFFF"/>
-                </a:solidFill>
-              </a:rPr>
-              <a:t>→ 1 token  (d=512)</a:t>
-            </a:r>
-          </a:p>
-        </p:txBody>
-      </p:sp>
-      <p:sp>
-        <p:nvSpPr>
-          <p:cNvPr id="18" name="Rounded Rectangle 17"/>
-          <p:cNvSpPr/>
-          <p:nvPr/>
-        </p:nvSpPr>
-        <p:spPr>
-          <a:xfrm>
-            <a:off x="4334255" y="5769864"/>
-            <a:ext cx="1920239" cy="987552"/>
-          </a:xfrm>
-          <a:prstGeom prst="roundRect">
-            <a:avLst>
-              <a:gd name="adj" fmla="val 4000"/>
-            </a:avLst>
-          </a:prstGeom>
-          <a:solidFill>
-            <a:srgbClr val="37474F"/>
-          </a:solidFill>
-          <a:ln w="38100">
-            <a:solidFill>
-              <a:srgbClr val="80DEEA"/>
-            </a:solidFill>
-            <a:prstDash val="dash"/>
-          </a:ln>
-        </p:spPr>
-        <p:style>
-          <a:lnRef idx="1">
-            <a:schemeClr val="accent1"/>
-          </a:lnRef>
-          <a:fillRef idx="3">
-            <a:schemeClr val="accent1"/>
-          </a:fillRef>
-          <a:effectRef idx="2">
-            <a:schemeClr val="accent1"/>
-          </a:effectRef>
-          <a:fontRef idx="minor">
-            <a:schemeClr val="lt1"/>
-          </a:fontRef>
-        </p:style>
-        <p:txBody>
-          <a:bodyPr rtlCol="0" anchor="ctr" wrap="none"/>
-          <a:lstStyle/>
-          <a:p>
-            <a:pPr algn="ctr"/>
-            <a:r>
-              <a:rPr sz="1100" b="1">
-                <a:solidFill>
-                  <a:srgbClr val="FFFFFF"/>
-                </a:solidFill>
-              </a:rPr>
-              <a:t>CLIP Text Encoder</a:t>
-            </a:r>
-          </a:p>
-          <a:p>
-            <a:pPr algn="ctr"/>
-            <a:r>
-              <a:rPr sz="1000" b="1">
-                <a:solidFill>
-                  <a:srgbClr val="FFFFFF"/>
-                </a:solidFill>
-              </a:rPr>
-              <a:t>❄  FROZEN</a:t>
-            </a:r>
-          </a:p>
-          <a:p>
-            <a:pPr algn="ctr"/>
-            <a:r>
-              <a:rPr sz="800" b="0">
-                <a:solidFill>
-                  <a:srgbClr val="FFFFFF"/>
-                </a:solidFill>
-              </a:rPr>
-              <a:t>→ 1 token  (d=512)</a:t>
-            </a:r>
-          </a:p>
-        </p:txBody>
-      </p:sp>
-      <p:sp>
-        <p:nvSpPr>
-          <p:cNvPr id="19" name="Rounded Rectangle 18"/>
-          <p:cNvSpPr/>
-          <p:nvPr/>
-        </p:nvSpPr>
-        <p:spPr>
-          <a:xfrm>
-            <a:off x="6400799" y="5769864"/>
-            <a:ext cx="1920239" cy="987552"/>
-          </a:xfrm>
-          <a:prstGeom prst="roundRect">
-            <a:avLst>
-              <a:gd name="adj" fmla="val 4000"/>
-            </a:avLst>
-          </a:prstGeom>
-          <a:solidFill>
-            <a:srgbClr val="37474F"/>
-          </a:solidFill>
-          <a:ln w="38100">
-            <a:solidFill>
-              <a:srgbClr val="80DEEA"/>
-            </a:solidFill>
-            <a:prstDash val="dash"/>
-          </a:ln>
-        </p:spPr>
-        <p:style>
-          <a:lnRef idx="1">
-            <a:schemeClr val="accent1"/>
-          </a:lnRef>
-          <a:fillRef idx="3">
-            <a:schemeClr val="accent1"/>
-          </a:fillRef>
-          <a:effectRef idx="2">
-            <a:schemeClr val="accent1"/>
-          </a:effectRef>
-          <a:fontRef idx="minor">
-            <a:schemeClr val="lt1"/>
-          </a:fontRef>
-        </p:style>
-        <p:txBody>
-          <a:bodyPr rtlCol="0" anchor="ctr" wrap="none"/>
-          <a:lstStyle/>
-          <a:p>
-            <a:pPr algn="ctr"/>
-            <a:r>
-              <a:rPr sz="1100" b="1">
-                <a:solidFill>
-                  <a:srgbClr val="FFFFFF"/>
-                </a:solidFill>
-              </a:rPr>
-              <a:t>CLIP Text Encoder</a:t>
-            </a:r>
-          </a:p>
-          <a:p>
-            <a:pPr algn="ctr"/>
-            <a:r>
-              <a:rPr sz="1000" b="1">
-                <a:solidFill>
-                  <a:srgbClr val="FFFFFF"/>
-                </a:solidFill>
-              </a:rPr>
-              <a:t>❄  FROZEN</a:t>
-            </a:r>
-          </a:p>
-          <a:p>
-            <a:pPr algn="ctr"/>
-            <a:r>
-              <a:rPr sz="800" b="0">
-                <a:solidFill>
-                  <a:srgbClr val="FFFFFF"/>
-                </a:solidFill>
-              </a:rPr>
-              <a:t>→ 1 token  (d=512)</a:t>
-            </a:r>
-          </a:p>
-        </p:txBody>
-      </p:sp>
-      <p:sp>
-        <p:nvSpPr>
-          <p:cNvPr id="20" name="Rounded Rectangle 19"/>
-          <p:cNvSpPr/>
-          <p:nvPr/>
-        </p:nvSpPr>
-        <p:spPr>
-          <a:xfrm>
-            <a:off x="8467344" y="5769864"/>
-            <a:ext cx="914399" cy="987552"/>
-          </a:xfrm>
-          <a:prstGeom prst="roundRect">
-            <a:avLst>
-              <a:gd name="adj" fmla="val 4000"/>
-            </a:avLst>
-          </a:prstGeom>
-          <a:solidFill>
-            <a:srgbClr val="6A1B9A"/>
-          </a:solidFill>
-          <a:ln>
-            <a:noFill/>
-          </a:ln>
-        </p:spPr>
-        <p:style>
-          <a:lnRef idx="1">
-            <a:schemeClr val="accent1"/>
-          </a:lnRef>
-          <a:fillRef idx="3">
-            <a:schemeClr val="accent1"/>
-          </a:fillRef>
-          <a:effectRef idx="2">
-            <a:schemeClr val="accent1"/>
-          </a:effectRef>
-          <a:fontRef idx="minor">
-            <a:schemeClr val="lt1"/>
-          </a:fontRef>
-        </p:style>
-        <p:txBody>
-          <a:bodyPr rtlCol="0" anchor="ctr" wrap="none"/>
-          <a:lstStyle/>
-          <a:p>
-            <a:pPr algn="ctr"/>
-            <a:r>
-              <a:rPr sz="1000" b="1">
-                <a:solidFill>
-                  <a:srgbClr val="FFFFFF"/>
-                </a:solidFill>
-              </a:rPr>
-              <a:t>History</a:t>
-            </a:r>
-          </a:p>
-          <a:p>
-            <a:pPr algn="ctr"/>
-            <a:r>
-              <a:rPr sz="900" b="0">
-                <a:solidFill>
-                  <a:srgbClr val="FFFFFF"/>
-                </a:solidFill>
-              </a:rPr>
-              <a:t>Encoder</a:t>
-            </a:r>
-          </a:p>
-          <a:p>
-            <a:pPr algn="ctr"/>
-            <a:r>
-              <a:rPr sz="800" b="0">
-                <a:solidFill>
-                  <a:srgbClr val="FFFFFF"/>
-                </a:solidFill>
-              </a:rPr>
-              <a:t>gate(a,r)</a:t>
-            </a:r>
-          </a:p>
-        </p:txBody>
-      </p:sp>
-      <p:sp>
-        <p:nvSpPr>
-          <p:cNvPr id="21" name="Rounded Rectangle 20"/>
-          <p:cNvSpPr/>
-          <p:nvPr/>
-        </p:nvSpPr>
-        <p:spPr>
-          <a:xfrm>
-            <a:off x="9473184" y="5769864"/>
-            <a:ext cx="914399" cy="987552"/>
+            <a:off x="99752" y="5780314"/>
+            <a:ext cx="1808849" cy="822960"/>
           </a:xfrm>
           <a:prstGeom prst="roundRect">
             <a:avLst>
@@ -4197,233 +3546,37 @@
           <a:p>
             <a:pPr algn="ctr"/>
             <a:r>
-              <a:rPr sz="1000" b="1">
+              <a:rPr sz="900" b="1">
                 <a:solidFill>
                   <a:srgbClr val="FFFFFF"/>
                 </a:solidFill>
               </a:rPr>
-              <a:t>2L Causal</a:t>
+              <a:t>History</a:t>
             </a:r>
           </a:p>
           <a:p>
             <a:pPr algn="ctr"/>
             <a:r>
-              <a:rPr sz="900" b="0">
+              <a:rPr sz="800" b="0">
                 <a:solidFill>
                   <a:srgbClr val="FFFFFF"/>
                 </a:solidFill>
               </a:rPr>
-              <a:t>LLaMA</a:t>
-            </a:r>
-          </a:p>
-          <a:p>
-            <a:pPr algn="ctr"/>
-            <a:r>
-              <a:rPr sz="800" b="0">
-                <a:solidFill>
-                  <a:srgbClr val="FFFFFF"/>
-                </a:solidFill>
-              </a:rPr>
-              <a:t>Sub-TF</a:t>
-            </a:r>
-          </a:p>
-        </p:txBody>
-      </p:sp>
-      <p:cxnSp>
-        <p:nvCxnSpPr>
-          <p:cNvPr id="22" name="Connector 21"/>
-          <p:cNvCxnSpPr/>
-          <p:nvPr/>
-        </p:nvCxnSpPr>
-        <p:spPr>
-          <a:xfrm flipV="1">
-            <a:off x="1161287" y="5586983"/>
-            <a:ext cx="0" cy="182881"/>
-          </a:xfrm>
-          <a:prstGeom prst="line">
-            <a:avLst/>
-          </a:prstGeom>
-          <a:ln w="22860">
-            <a:solidFill>
-              <a:srgbClr val="555555"/>
-            </a:solidFill>
-            <a:tailEnd type="none"/>
-            <a:headEnd type="arrow" w="med" len="med"/>
-          </a:ln>
-        </p:spPr>
-        <p:style>
-          <a:lnRef idx="2">
-            <a:schemeClr val="accent1"/>
-          </a:lnRef>
-          <a:fillRef idx="0">
-            <a:schemeClr val="accent1"/>
-          </a:fillRef>
-          <a:effectRef idx="1">
-            <a:schemeClr val="accent1"/>
-          </a:effectRef>
-          <a:fontRef idx="minor">
-            <a:schemeClr val="tx1"/>
-          </a:fontRef>
-        </p:style>
-      </p:cxnSp>
-      <p:cxnSp>
-        <p:nvCxnSpPr>
-          <p:cNvPr id="23" name="Connector 22"/>
-          <p:cNvCxnSpPr/>
-          <p:nvPr/>
-        </p:nvCxnSpPr>
-        <p:spPr>
-          <a:xfrm flipV="1">
-            <a:off x="3227832" y="5586983"/>
-            <a:ext cx="0" cy="182881"/>
-          </a:xfrm>
-          <a:prstGeom prst="line">
-            <a:avLst/>
-          </a:prstGeom>
-          <a:ln w="22860">
-            <a:solidFill>
-              <a:srgbClr val="555555"/>
-            </a:solidFill>
-            <a:tailEnd type="none"/>
-            <a:headEnd type="arrow" w="med" len="med"/>
-          </a:ln>
-        </p:spPr>
-        <p:style>
-          <a:lnRef idx="2">
-            <a:schemeClr val="accent1"/>
-          </a:lnRef>
-          <a:fillRef idx="0">
-            <a:schemeClr val="accent1"/>
-          </a:fillRef>
-          <a:effectRef idx="1">
-            <a:schemeClr val="accent1"/>
-          </a:effectRef>
-          <a:fontRef idx="minor">
-            <a:schemeClr val="tx1"/>
-          </a:fontRef>
-        </p:style>
-      </p:cxnSp>
-      <p:cxnSp>
-        <p:nvCxnSpPr>
-          <p:cNvPr id="24" name="Connector 23"/>
-          <p:cNvCxnSpPr/>
-          <p:nvPr/>
-        </p:nvCxnSpPr>
-        <p:spPr>
-          <a:xfrm flipV="1">
-            <a:off x="5294375" y="5586983"/>
-            <a:ext cx="0" cy="182881"/>
-          </a:xfrm>
-          <a:prstGeom prst="line">
-            <a:avLst/>
-          </a:prstGeom>
-          <a:ln w="22860">
-            <a:solidFill>
-              <a:srgbClr val="555555"/>
-            </a:solidFill>
-            <a:tailEnd type="none"/>
-            <a:headEnd type="arrow" w="med" len="med"/>
-          </a:ln>
-        </p:spPr>
-        <p:style>
-          <a:lnRef idx="2">
-            <a:schemeClr val="accent1"/>
-          </a:lnRef>
-          <a:fillRef idx="0">
-            <a:schemeClr val="accent1"/>
-          </a:fillRef>
-          <a:effectRef idx="1">
-            <a:schemeClr val="accent1"/>
-          </a:effectRef>
-          <a:fontRef idx="minor">
-            <a:schemeClr val="tx1"/>
-          </a:fontRef>
-        </p:style>
-      </p:cxnSp>
-      <p:cxnSp>
-        <p:nvCxnSpPr>
-          <p:cNvPr id="25" name="Connector 24"/>
-          <p:cNvCxnSpPr/>
-          <p:nvPr/>
-        </p:nvCxnSpPr>
-        <p:spPr>
-          <a:xfrm flipV="1">
-            <a:off x="7360919" y="5586983"/>
-            <a:ext cx="0" cy="182881"/>
-          </a:xfrm>
-          <a:prstGeom prst="line">
-            <a:avLst/>
-          </a:prstGeom>
-          <a:ln w="22860">
-            <a:solidFill>
-              <a:srgbClr val="555555"/>
-            </a:solidFill>
-            <a:tailEnd type="none"/>
-            <a:headEnd type="arrow" w="med" len="med"/>
-          </a:ln>
-        </p:spPr>
-        <p:style>
-          <a:lnRef idx="2">
-            <a:schemeClr val="accent1"/>
-          </a:lnRef>
-          <a:fillRef idx="0">
-            <a:schemeClr val="accent1"/>
-          </a:fillRef>
-          <a:effectRef idx="1">
-            <a:schemeClr val="accent1"/>
-          </a:effectRef>
-          <a:fontRef idx="minor">
-            <a:schemeClr val="tx1"/>
-          </a:fontRef>
-        </p:style>
-      </p:cxnSp>
-      <p:cxnSp>
-        <p:nvCxnSpPr>
-          <p:cNvPr id="26" name="Connector 25"/>
-          <p:cNvCxnSpPr/>
-          <p:nvPr/>
-        </p:nvCxnSpPr>
-        <p:spPr>
-          <a:xfrm flipV="1">
-            <a:off x="9427463" y="5586983"/>
-            <a:ext cx="0" cy="182881"/>
-          </a:xfrm>
-          <a:prstGeom prst="line">
-            <a:avLst/>
-          </a:prstGeom>
-          <a:ln w="22860">
-            <a:solidFill>
-              <a:srgbClr val="555555"/>
-            </a:solidFill>
-            <a:tailEnd type="none"/>
-            <a:headEnd type="arrow" w="med" len="med"/>
-          </a:ln>
-        </p:spPr>
-        <p:style>
-          <a:lnRef idx="2">
-            <a:schemeClr val="accent1"/>
-          </a:lnRef>
-          <a:fillRef idx="0">
-            <a:schemeClr val="accent1"/>
-          </a:fillRef>
-          <a:effectRef idx="1">
-            <a:schemeClr val="accent1"/>
-          </a:effectRef>
-          <a:fontRef idx="minor">
-            <a:schemeClr val="tx1"/>
-          </a:fontRef>
-        </p:style>
-      </p:cxnSp>
-      <p:sp>
-        <p:nvSpPr>
-          <p:cNvPr id="27" name="Rounded Rectangle 26"/>
+              <a:t>H=4 (action, reward) pairs</a:t>
+            </a:r>
+          </a:p>
+        </p:txBody>
+      </p:sp>
+      <p:sp>
+        <p:nvSpPr>
+          <p:cNvPr id="11" name="Rounded Rectangle 10"/>
           <p:cNvSpPr/>
           <p:nvPr/>
         </p:nvSpPr>
         <p:spPr>
           <a:xfrm>
-            <a:off x="201168" y="5239512"/>
-            <a:ext cx="10186415" cy="347472"/>
+            <a:off x="1443089" y="4620332"/>
+            <a:ext cx="399010" cy="203780"/>
           </a:xfrm>
           <a:prstGeom prst="roundRect">
             <a:avLst>
@@ -4431,12 +3584,10 @@
             </a:avLst>
           </a:prstGeom>
           <a:solidFill>
-            <a:srgbClr val="E0F2F1"/>
+            <a:srgbClr val="C62828"/>
           </a:solidFill>
-          <a:ln w="22860">
-            <a:solidFill>
-              <a:srgbClr val="00695C"/>
-            </a:solidFill>
+          <a:ln>
+            <a:noFill/>
           </a:ln>
         </p:spPr>
         <p:style>
@@ -4459,211 +3610,26 @@
           <a:p>
             <a:pPr algn="ctr"/>
             <a:r>
-              <a:rPr sz="1050" b="1">
-                <a:solidFill>
-                  <a:srgbClr val="004D40"/>
+              <a:rPr sz="700" b="1">
+                <a:solidFill>
+                  <a:srgbClr val="FFFFFF"/>
                 </a:solidFill>
               </a:rPr>
-              <a:t>Independent  RMSNorm + Linear  →  d = 256   +   ViLT modality-type embedding per stream</a:t>
-            </a:r>
-          </a:p>
-        </p:txBody>
-      </p:sp>
-      <p:cxnSp>
-        <p:nvCxnSpPr>
-          <p:cNvPr id="28" name="Connector 27"/>
-          <p:cNvCxnSpPr/>
-          <p:nvPr/>
-        </p:nvCxnSpPr>
-        <p:spPr>
-          <a:xfrm flipV="1">
-            <a:off x="1161287" y="5056631"/>
-            <a:ext cx="0" cy="182881"/>
-          </a:xfrm>
-          <a:prstGeom prst="line">
-            <a:avLst/>
-          </a:prstGeom>
-          <a:ln w="22860">
-            <a:solidFill>
-              <a:srgbClr val="555555"/>
-            </a:solidFill>
-            <a:tailEnd type="none"/>
-            <a:headEnd type="arrow" w="med" len="med"/>
-          </a:ln>
-        </p:spPr>
-        <p:style>
-          <a:lnRef idx="2">
-            <a:schemeClr val="accent1"/>
-          </a:lnRef>
-          <a:fillRef idx="0">
-            <a:schemeClr val="accent1"/>
-          </a:fillRef>
-          <a:effectRef idx="1">
-            <a:schemeClr val="accent1"/>
-          </a:effectRef>
-          <a:fontRef idx="minor">
-            <a:schemeClr val="tx1"/>
-          </a:fontRef>
-        </p:style>
-      </p:cxnSp>
-      <p:cxnSp>
-        <p:nvCxnSpPr>
-          <p:cNvPr id="29" name="Connector 28"/>
-          <p:cNvCxnSpPr/>
-          <p:nvPr/>
-        </p:nvCxnSpPr>
-        <p:spPr>
-          <a:xfrm flipV="1">
-            <a:off x="3227832" y="5056631"/>
-            <a:ext cx="0" cy="182881"/>
-          </a:xfrm>
-          <a:prstGeom prst="line">
-            <a:avLst/>
-          </a:prstGeom>
-          <a:ln w="22860">
-            <a:solidFill>
-              <a:srgbClr val="555555"/>
-            </a:solidFill>
-            <a:tailEnd type="none"/>
-            <a:headEnd type="arrow" w="med" len="med"/>
-          </a:ln>
-        </p:spPr>
-        <p:style>
-          <a:lnRef idx="2">
-            <a:schemeClr val="accent1"/>
-          </a:lnRef>
-          <a:fillRef idx="0">
-            <a:schemeClr val="accent1"/>
-          </a:fillRef>
-          <a:effectRef idx="1">
-            <a:schemeClr val="accent1"/>
-          </a:effectRef>
-          <a:fontRef idx="minor">
-            <a:schemeClr val="tx1"/>
-          </a:fontRef>
-        </p:style>
-      </p:cxnSp>
-      <p:cxnSp>
-        <p:nvCxnSpPr>
-          <p:cNvPr id="30" name="Connector 29"/>
-          <p:cNvCxnSpPr/>
-          <p:nvPr/>
-        </p:nvCxnSpPr>
-        <p:spPr>
-          <a:xfrm flipV="1">
-            <a:off x="5294375" y="5056631"/>
-            <a:ext cx="0" cy="182881"/>
-          </a:xfrm>
-          <a:prstGeom prst="line">
-            <a:avLst/>
-          </a:prstGeom>
-          <a:ln w="22860">
-            <a:solidFill>
-              <a:srgbClr val="555555"/>
-            </a:solidFill>
-            <a:tailEnd type="none"/>
-            <a:headEnd type="arrow" w="med" len="med"/>
-          </a:ln>
-        </p:spPr>
-        <p:style>
-          <a:lnRef idx="2">
-            <a:schemeClr val="accent1"/>
-          </a:lnRef>
-          <a:fillRef idx="0">
-            <a:schemeClr val="accent1"/>
-          </a:fillRef>
-          <a:effectRef idx="1">
-            <a:schemeClr val="accent1"/>
-          </a:effectRef>
-          <a:fontRef idx="minor">
-            <a:schemeClr val="tx1"/>
-          </a:fontRef>
-        </p:style>
-      </p:cxnSp>
-      <p:cxnSp>
-        <p:nvCxnSpPr>
-          <p:cNvPr id="31" name="Connector 30"/>
-          <p:cNvCxnSpPr/>
-          <p:nvPr/>
-        </p:nvCxnSpPr>
-        <p:spPr>
-          <a:xfrm flipV="1">
-            <a:off x="7360919" y="5056631"/>
-            <a:ext cx="0" cy="182881"/>
-          </a:xfrm>
-          <a:prstGeom prst="line">
-            <a:avLst/>
-          </a:prstGeom>
-          <a:ln w="22860">
-            <a:solidFill>
-              <a:srgbClr val="555555"/>
-            </a:solidFill>
-            <a:tailEnd type="none"/>
-            <a:headEnd type="arrow" w="med" len="med"/>
-          </a:ln>
-        </p:spPr>
-        <p:style>
-          <a:lnRef idx="2">
-            <a:schemeClr val="accent1"/>
-          </a:lnRef>
-          <a:fillRef idx="0">
-            <a:schemeClr val="accent1"/>
-          </a:fillRef>
-          <a:effectRef idx="1">
-            <a:schemeClr val="accent1"/>
-          </a:effectRef>
-          <a:fontRef idx="minor">
-            <a:schemeClr val="tx1"/>
-          </a:fontRef>
-        </p:style>
-      </p:cxnSp>
-      <p:cxnSp>
-        <p:nvCxnSpPr>
-          <p:cNvPr id="32" name="Connector 31"/>
-          <p:cNvCxnSpPr/>
-          <p:nvPr/>
-        </p:nvCxnSpPr>
-        <p:spPr>
-          <a:xfrm flipV="1">
-            <a:off x="9427463" y="5056631"/>
-            <a:ext cx="0" cy="182881"/>
-          </a:xfrm>
-          <a:prstGeom prst="line">
-            <a:avLst/>
-          </a:prstGeom>
-          <a:ln w="22860">
-            <a:solidFill>
-              <a:srgbClr val="555555"/>
-            </a:solidFill>
-            <a:tailEnd type="none"/>
-            <a:headEnd type="arrow" w="med" len="med"/>
-          </a:ln>
-        </p:spPr>
-        <p:style>
-          <a:lnRef idx="2">
-            <a:schemeClr val="accent1"/>
-          </a:lnRef>
-          <a:fillRef idx="0">
-            <a:schemeClr val="accent1"/>
-          </a:fillRef>
-          <a:effectRef idx="1">
-            <a:schemeClr val="accent1"/>
-          </a:effectRef>
-          <a:fontRef idx="minor">
-            <a:schemeClr val="tx1"/>
-          </a:fontRef>
-        </p:style>
-      </p:cxnSp>
-      <p:sp>
-        <p:nvSpPr>
-          <p:cNvPr id="33" name="Rounded Rectangle 32"/>
+              <a:t>NEW</a:t>
+            </a:r>
+          </a:p>
+        </p:txBody>
+      </p:sp>
+      <p:sp>
+        <p:nvSpPr>
+          <p:cNvPr id="12" name="Rounded Rectangle 11"/>
           <p:cNvSpPr/>
           <p:nvPr/>
         </p:nvSpPr>
         <p:spPr>
           <a:xfrm>
-            <a:off x="201168" y="2724911"/>
-            <a:ext cx="10186415" cy="2331720"/>
+            <a:off x="2892829" y="501613"/>
+            <a:ext cx="319208" cy="376210"/>
           </a:xfrm>
           <a:prstGeom prst="roundRect">
             <a:avLst>
@@ -4673,9 +3639,9 @@
           <a:solidFill>
             <a:srgbClr val="1A237E"/>
           </a:solidFill>
-          <a:ln w="31750">
+          <a:ln w="22860">
             <a:solidFill>
-              <a:srgbClr val="7986CB"/>
+              <a:srgbClr val="90CAF9"/>
             </a:solidFill>
           </a:ln>
         </p:spPr>
@@ -4698,72 +3664,27 @@
           <a:lstStyle/>
           <a:p>
             <a:pPr algn="ctr"/>
-          </a:p>
-        </p:txBody>
-      </p:sp>
-      <p:sp>
-        <p:nvSpPr>
-          <p:cNvPr id="34" name="Rounded Rectangle 33"/>
+            <a:r>
+              <a:rPr sz="900" b="1">
+                <a:solidFill>
+                  <a:srgbClr val="FFFFFF"/>
+                </a:solidFill>
+              </a:rPr>
+              <a:t>1</a:t>
+            </a:r>
+          </a:p>
+        </p:txBody>
+      </p:sp>
+      <p:sp>
+        <p:nvSpPr>
+          <p:cNvPr id="13" name="Rounded Rectangle 12"/>
           <p:cNvSpPr/>
           <p:nvPr/>
         </p:nvSpPr>
         <p:spPr>
           <a:xfrm>
-            <a:off x="310896" y="2816351"/>
-            <a:ext cx="9966959" cy="438912"/>
-          </a:xfrm>
-          <a:prstGeom prst="roundRect">
-            <a:avLst>
-              <a:gd name="adj" fmla="val 4000"/>
-            </a:avLst>
-          </a:prstGeom>
-          <a:solidFill>
-            <a:srgbClr val="283593"/>
-          </a:solidFill>
-          <a:ln>
-            <a:noFill/>
-          </a:ln>
-        </p:spPr>
-        <p:style>
-          <a:lnRef idx="1">
-            <a:schemeClr val="accent1"/>
-          </a:lnRef>
-          <a:fillRef idx="3">
-            <a:schemeClr val="accent1"/>
-          </a:fillRef>
-          <a:effectRef idx="2">
-            <a:schemeClr val="accent1"/>
-          </a:effectRef>
-          <a:fontRef idx="minor">
-            <a:schemeClr val="lt1"/>
-          </a:fontRef>
-        </p:style>
-        <p:txBody>
-          <a:bodyPr rtlCol="0" anchor="ctr" wrap="none"/>
-          <a:lstStyle/>
-          <a:p>
-            <a:pPr algn="ctr"/>
-            <a:r>
-              <a:rPr sz="1050" b="1">
-                <a:solidFill>
-                  <a:srgbClr val="FFFFFF"/>
-                </a:solidFill>
-              </a:rPr>
-              <a:t>LLaMA Fusion Transformer   ·   6 Layers   ·   8 Heads   ·   d_model = 256   ·   d_ff = 1024   ·   RMSNorm · RoPE · SwiGLU</a:t>
-            </a:r>
-          </a:p>
-        </p:txBody>
-      </p:sp>
-      <p:sp>
-        <p:nvSpPr>
-          <p:cNvPr id="35" name="Rounded Rectangle 34"/>
-          <p:cNvSpPr/>
-          <p:nvPr/>
-        </p:nvSpPr>
-        <p:spPr>
-          <a:xfrm>
-            <a:off x="310896" y="3310127"/>
-            <a:ext cx="9966959" cy="329184"/>
+            <a:off x="3650949" y="501613"/>
+            <a:ext cx="319208" cy="376210"/>
           </a:xfrm>
           <a:prstGeom prst="roundRect">
             <a:avLst>
@@ -4773,9 +3694,9 @@
           <a:solidFill>
             <a:srgbClr val="1A237E"/>
           </a:solidFill>
-          <a:ln w="31750">
+          <a:ln w="22860">
             <a:solidFill>
-              <a:srgbClr val="FFD54F"/>
+              <a:srgbClr val="90CAF9"/>
             </a:solidFill>
           </a:ln>
         </p:spPr>
@@ -4799,26 +3720,669 @@
           <a:p>
             <a:pPr algn="ctr"/>
             <a:r>
-              <a:rPr sz="1050" b="1">
-                <a:solidFill>
-                  <a:srgbClr val="FFD54F"/>
+              <a:rPr sz="900" b="1">
+                <a:solidFill>
+                  <a:srgbClr val="FFFFFF"/>
                 </a:solidFill>
               </a:rPr>
-              <a:t>◈   BIDIRECTIONAL  —  Full Attention  —  No Causal Mask   ◈</a:t>
-            </a:r>
-          </a:p>
-        </p:txBody>
-      </p:sp>
-      <p:sp>
-        <p:nvSpPr>
-          <p:cNvPr id="36" name="Rounded Rectangle 35"/>
+              <a:t>2</a:t>
+            </a:r>
+          </a:p>
+        </p:txBody>
+      </p:sp>
+      <p:sp>
+        <p:nvSpPr>
+          <p:cNvPr id="14" name="Rounded Rectangle 13"/>
           <p:cNvSpPr/>
           <p:nvPr/>
         </p:nvSpPr>
         <p:spPr>
           <a:xfrm>
-            <a:off x="310896" y="3712463"/>
-            <a:ext cx="9966959" cy="347472"/>
+            <a:off x="5433198" y="501613"/>
+            <a:ext cx="319208" cy="376210"/>
+          </a:xfrm>
+          <a:prstGeom prst="roundRect">
+            <a:avLst>
+              <a:gd name="adj" fmla="val 4000"/>
+            </a:avLst>
+          </a:prstGeom>
+          <a:solidFill>
+            <a:srgbClr val="1A237E"/>
+          </a:solidFill>
+          <a:ln w="22860">
+            <a:solidFill>
+              <a:srgbClr val="90CAF9"/>
+            </a:solidFill>
+          </a:ln>
+        </p:spPr>
+        <p:style>
+          <a:lnRef idx="1">
+            <a:schemeClr val="accent1"/>
+          </a:lnRef>
+          <a:fillRef idx="3">
+            <a:schemeClr val="accent1"/>
+          </a:fillRef>
+          <a:effectRef idx="2">
+            <a:schemeClr val="accent1"/>
+          </a:effectRef>
+          <a:fontRef idx="minor">
+            <a:schemeClr val="lt1"/>
+          </a:fontRef>
+        </p:style>
+        <p:txBody>
+          <a:bodyPr rtlCol="0" anchor="ctr" wrap="none"/>
+          <a:lstStyle/>
+          <a:p>
+            <a:pPr algn="ctr"/>
+            <a:r>
+              <a:rPr sz="900" b="1">
+                <a:solidFill>
+                  <a:srgbClr val="FFFFFF"/>
+                </a:solidFill>
+              </a:rPr>
+              <a:t>3</a:t>
+            </a:r>
+          </a:p>
+        </p:txBody>
+      </p:sp>
+      <p:sp>
+        <p:nvSpPr>
+          <p:cNvPr id="15" name="Rounded Rectangle 14"/>
+          <p:cNvSpPr/>
+          <p:nvPr/>
+        </p:nvSpPr>
+        <p:spPr>
+          <a:xfrm>
+            <a:off x="9187226" y="501613"/>
+            <a:ext cx="319208" cy="376210"/>
+          </a:xfrm>
+          <a:prstGeom prst="roundRect">
+            <a:avLst>
+              <a:gd name="adj" fmla="val 4000"/>
+            </a:avLst>
+          </a:prstGeom>
+          <a:solidFill>
+            <a:srgbClr val="1A237E"/>
+          </a:solidFill>
+          <a:ln w="22860">
+            <a:solidFill>
+              <a:srgbClr val="90CAF9"/>
+            </a:solidFill>
+          </a:ln>
+        </p:spPr>
+        <p:style>
+          <a:lnRef idx="1">
+            <a:schemeClr val="accent1"/>
+          </a:lnRef>
+          <a:fillRef idx="3">
+            <a:schemeClr val="accent1"/>
+          </a:fillRef>
+          <a:effectRef idx="2">
+            <a:schemeClr val="accent1"/>
+          </a:effectRef>
+          <a:fontRef idx="minor">
+            <a:schemeClr val="lt1"/>
+          </a:fontRef>
+        </p:style>
+        <p:txBody>
+          <a:bodyPr rtlCol="0" anchor="ctr" wrap="none"/>
+          <a:lstStyle/>
+          <a:p>
+            <a:pPr algn="ctr"/>
+            <a:r>
+              <a:rPr sz="900" b="1">
+                <a:solidFill>
+                  <a:srgbClr val="FFFFFF"/>
+                </a:solidFill>
+              </a:rPr>
+              <a:t>4</a:t>
+            </a:r>
+          </a:p>
+        </p:txBody>
+      </p:sp>
+      <p:sp>
+        <p:nvSpPr>
+          <p:cNvPr id="16" name="Rounded Rectangle 15"/>
+          <p:cNvSpPr/>
+          <p:nvPr/>
+        </p:nvSpPr>
+        <p:spPr>
+          <a:xfrm>
+            <a:off x="2427316" y="815122"/>
+            <a:ext cx="1250234" cy="1034578"/>
+          </a:xfrm>
+          <a:prstGeom prst="roundRect">
+            <a:avLst>
+              <a:gd name="adj" fmla="val 4000"/>
+            </a:avLst>
+          </a:prstGeom>
+          <a:solidFill>
+            <a:srgbClr val="1565C0"/>
+          </a:solidFill>
+          <a:ln w="35560">
+            <a:solidFill>
+              <a:srgbClr val="66BB6A"/>
+            </a:solidFill>
+          </a:ln>
+        </p:spPr>
+        <p:style>
+          <a:lnRef idx="1">
+            <a:schemeClr val="accent1"/>
+          </a:lnRef>
+          <a:fillRef idx="3">
+            <a:schemeClr val="accent1"/>
+          </a:fillRef>
+          <a:effectRef idx="2">
+            <a:schemeClr val="accent1"/>
+          </a:effectRef>
+          <a:fontRef idx="minor">
+            <a:schemeClr val="lt1"/>
+          </a:fontRef>
+        </p:style>
+        <p:txBody>
+          <a:bodyPr rtlCol="0" anchor="ctr" wrap="none"/>
+          <a:lstStyle/>
+          <a:p>
+            <a:pPr algn="ctr"/>
+            <a:r>
+              <a:rPr sz="900" b="1">
+                <a:solidFill>
+                  <a:srgbClr val="FFFFFF"/>
+                </a:solidFill>
+              </a:rPr>
+              <a:t>CLIP ViT-B/32</a:t>
+            </a:r>
+          </a:p>
+          <a:p>
+            <a:pPr algn="ctr"/>
+            <a:r>
+              <a:rPr sz="850" b="1">
+                <a:solidFill>
+                  <a:srgbClr val="FFFFFF"/>
+                </a:solidFill>
+              </a:rPr>
+              <a:t>✓ fine-tuned</a:t>
+            </a:r>
+          </a:p>
+          <a:p>
+            <a:pPr algn="ctr"/>
+            <a:r>
+              <a:rPr sz="750" b="0">
+                <a:solidFill>
+                  <a:srgbClr val="FFFFFF"/>
+                </a:solidFill>
+              </a:rPr>
+              <a:t>lr=3e-6 · 197 patches</a:t>
+            </a:r>
+          </a:p>
+        </p:txBody>
+      </p:sp>
+      <p:sp>
+        <p:nvSpPr>
+          <p:cNvPr id="17" name="Rounded Rectangle 16"/>
+          <p:cNvSpPr/>
+          <p:nvPr/>
+        </p:nvSpPr>
+        <p:spPr>
+          <a:xfrm>
+            <a:off x="2427316" y="2210235"/>
+            <a:ext cx="1250234" cy="674043"/>
+          </a:xfrm>
+          <a:prstGeom prst="roundRect">
+            <a:avLst>
+              <a:gd name="adj" fmla="val 4000"/>
+            </a:avLst>
+          </a:prstGeom>
+          <a:solidFill>
+            <a:srgbClr val="37474F"/>
+          </a:solidFill>
+          <a:ln w="25400">
+            <a:solidFill>
+              <a:srgbClr val="4DD0E1"/>
+            </a:solidFill>
+            <a:prstDash val="dash"/>
+          </a:ln>
+        </p:spPr>
+        <p:style>
+          <a:lnRef idx="1">
+            <a:schemeClr val="accent1"/>
+          </a:lnRef>
+          <a:fillRef idx="3">
+            <a:schemeClr val="accent1"/>
+          </a:fillRef>
+          <a:effectRef idx="2">
+            <a:schemeClr val="accent1"/>
+          </a:effectRef>
+          <a:fontRef idx="minor">
+            <a:schemeClr val="lt1"/>
+          </a:fontRef>
+        </p:style>
+        <p:txBody>
+          <a:bodyPr rtlCol="0" anchor="ctr" wrap="none"/>
+          <a:lstStyle/>
+          <a:p>
+            <a:pPr algn="ctr"/>
+            <a:r>
+              <a:rPr sz="850" b="1">
+                <a:solidFill>
+                  <a:srgbClr val="FFFFFF"/>
+                </a:solidFill>
+              </a:rPr>
+              <a:t>CLIP Text Encoder</a:t>
+            </a:r>
+          </a:p>
+          <a:p>
+            <a:pPr algn="ctr"/>
+            <a:r>
+              <a:rPr sz="800" b="1">
+                <a:solidFill>
+                  <a:srgbClr val="FFFFFF"/>
+                </a:solidFill>
+              </a:rPr>
+              <a:t>❄ FROZEN  ·  1 token</a:t>
+            </a:r>
+          </a:p>
+        </p:txBody>
+      </p:sp>
+      <p:sp>
+        <p:nvSpPr>
+          <p:cNvPr id="18" name="Rounded Rectangle 17"/>
+          <p:cNvSpPr/>
+          <p:nvPr/>
+        </p:nvSpPr>
+        <p:spPr>
+          <a:xfrm>
+            <a:off x="2427316" y="3425081"/>
+            <a:ext cx="1250234" cy="674043"/>
+          </a:xfrm>
+          <a:prstGeom prst="roundRect">
+            <a:avLst>
+              <a:gd name="adj" fmla="val 4000"/>
+            </a:avLst>
+          </a:prstGeom>
+          <a:solidFill>
+            <a:srgbClr val="37474F"/>
+          </a:solidFill>
+          <a:ln w="25400">
+            <a:solidFill>
+              <a:srgbClr val="4DD0E1"/>
+            </a:solidFill>
+            <a:prstDash val="dash"/>
+          </a:ln>
+        </p:spPr>
+        <p:style>
+          <a:lnRef idx="1">
+            <a:schemeClr val="accent1"/>
+          </a:lnRef>
+          <a:fillRef idx="3">
+            <a:schemeClr val="accent1"/>
+          </a:fillRef>
+          <a:effectRef idx="2">
+            <a:schemeClr val="accent1"/>
+          </a:effectRef>
+          <a:fontRef idx="minor">
+            <a:schemeClr val="lt1"/>
+          </a:fontRef>
+        </p:style>
+        <p:txBody>
+          <a:bodyPr rtlCol="0" anchor="ctr" wrap="none"/>
+          <a:lstStyle/>
+          <a:p>
+            <a:pPr algn="ctr"/>
+            <a:r>
+              <a:rPr sz="850" b="1">
+                <a:solidFill>
+                  <a:srgbClr val="FFFFFF"/>
+                </a:solidFill>
+              </a:rPr>
+              <a:t>CLIP Text Encoder</a:t>
+            </a:r>
+          </a:p>
+          <a:p>
+            <a:pPr algn="ctr"/>
+            <a:r>
+              <a:rPr sz="800" b="1">
+                <a:solidFill>
+                  <a:srgbClr val="FFFFFF"/>
+                </a:solidFill>
+              </a:rPr>
+              <a:t>❄ FROZEN  ·  1 token</a:t>
+            </a:r>
+          </a:p>
+        </p:txBody>
+      </p:sp>
+      <p:sp>
+        <p:nvSpPr>
+          <p:cNvPr id="19" name="Rounded Rectangle 18"/>
+          <p:cNvSpPr/>
+          <p:nvPr/>
+        </p:nvSpPr>
+        <p:spPr>
+          <a:xfrm>
+            <a:off x="2427316" y="4639926"/>
+            <a:ext cx="1250234" cy="674043"/>
+          </a:xfrm>
+          <a:prstGeom prst="roundRect">
+            <a:avLst>
+              <a:gd name="adj" fmla="val 4000"/>
+            </a:avLst>
+          </a:prstGeom>
+          <a:solidFill>
+            <a:srgbClr val="37474F"/>
+          </a:solidFill>
+          <a:ln w="25400">
+            <a:solidFill>
+              <a:srgbClr val="4DD0E1"/>
+            </a:solidFill>
+            <a:prstDash val="dash"/>
+          </a:ln>
+        </p:spPr>
+        <p:style>
+          <a:lnRef idx="1">
+            <a:schemeClr val="accent1"/>
+          </a:lnRef>
+          <a:fillRef idx="3">
+            <a:schemeClr val="accent1"/>
+          </a:fillRef>
+          <a:effectRef idx="2">
+            <a:schemeClr val="accent1"/>
+          </a:effectRef>
+          <a:fontRef idx="minor">
+            <a:schemeClr val="lt1"/>
+          </a:fontRef>
+        </p:style>
+        <p:txBody>
+          <a:bodyPr rtlCol="0" anchor="ctr" wrap="none"/>
+          <a:lstStyle/>
+          <a:p>
+            <a:pPr algn="ctr"/>
+            <a:r>
+              <a:rPr sz="850" b="1">
+                <a:solidFill>
+                  <a:srgbClr val="FFFFFF"/>
+                </a:solidFill>
+              </a:rPr>
+              <a:t>CLIP Text Encoder</a:t>
+            </a:r>
+          </a:p>
+          <a:p>
+            <a:pPr algn="ctr"/>
+            <a:r>
+              <a:rPr sz="800" b="1">
+                <a:solidFill>
+                  <a:srgbClr val="FFFFFF"/>
+                </a:solidFill>
+              </a:rPr>
+              <a:t>❄ FROZEN  ·  1 token</a:t>
+            </a:r>
+          </a:p>
+        </p:txBody>
+      </p:sp>
+      <p:sp>
+        <p:nvSpPr>
+          <p:cNvPr id="20" name="Rounded Rectangle 19"/>
+          <p:cNvSpPr/>
+          <p:nvPr/>
+        </p:nvSpPr>
+        <p:spPr>
+          <a:xfrm>
+            <a:off x="2427316" y="5752882"/>
+            <a:ext cx="598516" cy="877824"/>
+          </a:xfrm>
+          <a:prstGeom prst="roundRect">
+            <a:avLst>
+              <a:gd name="adj" fmla="val 4000"/>
+            </a:avLst>
+          </a:prstGeom>
+          <a:solidFill>
+            <a:srgbClr val="4527A0"/>
+          </a:solidFill>
+          <a:ln>
+            <a:noFill/>
+          </a:ln>
+        </p:spPr>
+        <p:style>
+          <a:lnRef idx="1">
+            <a:schemeClr val="accent1"/>
+          </a:lnRef>
+          <a:fillRef idx="3">
+            <a:schemeClr val="accent1"/>
+          </a:fillRef>
+          <a:effectRef idx="2">
+            <a:schemeClr val="accent1"/>
+          </a:effectRef>
+          <a:fontRef idx="minor">
+            <a:schemeClr val="lt1"/>
+          </a:fontRef>
+        </p:style>
+        <p:txBody>
+          <a:bodyPr rtlCol="0" anchor="ctr" wrap="none"/>
+          <a:lstStyle/>
+          <a:p>
+            <a:pPr algn="ctr"/>
+            <a:r>
+              <a:rPr sz="850" b="1">
+                <a:solidFill>
+                  <a:srgbClr val="FFFFFF"/>
+                </a:solidFill>
+              </a:rPr>
+              <a:t>History</a:t>
+            </a:r>
+          </a:p>
+          <a:p>
+            <a:pPr algn="ctr"/>
+            <a:r>
+              <a:rPr sz="800" b="0">
+                <a:solidFill>
+                  <a:srgbClr val="FFFFFF"/>
+                </a:solidFill>
+              </a:rPr>
+              <a:t>Encoder</a:t>
+            </a:r>
+          </a:p>
+        </p:txBody>
+      </p:sp>
+      <p:sp>
+        <p:nvSpPr>
+          <p:cNvPr id="21" name="Rounded Rectangle 20"/>
+          <p:cNvSpPr/>
+          <p:nvPr/>
+        </p:nvSpPr>
+        <p:spPr>
+          <a:xfrm>
+            <a:off x="3079034" y="5752882"/>
+            <a:ext cx="598516" cy="877824"/>
+          </a:xfrm>
+          <a:prstGeom prst="roundRect">
+            <a:avLst>
+              <a:gd name="adj" fmla="val 4000"/>
+            </a:avLst>
+          </a:prstGeom>
+          <a:solidFill>
+            <a:srgbClr val="4527A0"/>
+          </a:solidFill>
+          <a:ln>
+            <a:noFill/>
+          </a:ln>
+        </p:spPr>
+        <p:style>
+          <a:lnRef idx="1">
+            <a:schemeClr val="accent1"/>
+          </a:lnRef>
+          <a:fillRef idx="3">
+            <a:schemeClr val="accent1"/>
+          </a:fillRef>
+          <a:effectRef idx="2">
+            <a:schemeClr val="accent1"/>
+          </a:effectRef>
+          <a:fontRef idx="minor">
+            <a:schemeClr val="lt1"/>
+          </a:fontRef>
+        </p:style>
+        <p:txBody>
+          <a:bodyPr rtlCol="0" anchor="ctr" wrap="none"/>
+          <a:lstStyle/>
+          <a:p>
+            <a:pPr algn="ctr"/>
+            <a:r>
+              <a:rPr sz="850" b="1">
+                <a:solidFill>
+                  <a:srgbClr val="FFFFFF"/>
+                </a:solidFill>
+              </a:rPr>
+              <a:t>2L Causal</a:t>
+            </a:r>
+          </a:p>
+          <a:p>
+            <a:pPr algn="ctr"/>
+            <a:r>
+              <a:rPr sz="800" b="0">
+                <a:solidFill>
+                  <a:srgbClr val="FFFFFF"/>
+                </a:solidFill>
+              </a:rPr>
+              <a:t>LLaMA Sub-TF</a:t>
+            </a:r>
+          </a:p>
+        </p:txBody>
+      </p:sp>
+      <p:sp>
+        <p:nvSpPr>
+          <p:cNvPr id="22" name="Rounded Rectangle 21"/>
+          <p:cNvSpPr/>
+          <p:nvPr/>
+        </p:nvSpPr>
+        <p:spPr>
+          <a:xfrm>
+            <a:off x="3757352" y="1018902"/>
+            <a:ext cx="106402" cy="5486400"/>
+          </a:xfrm>
+          <a:prstGeom prst="roundRect">
+            <a:avLst>
+              <a:gd name="adj" fmla="val 4000"/>
+            </a:avLst>
+          </a:prstGeom>
+          <a:solidFill>
+            <a:srgbClr val="546E7A"/>
+          </a:solidFill>
+          <a:ln>
+            <a:noFill/>
+          </a:ln>
+        </p:spPr>
+        <p:style>
+          <a:lnRef idx="1">
+            <a:schemeClr val="accent1"/>
+          </a:lnRef>
+          <a:fillRef idx="3">
+            <a:schemeClr val="accent1"/>
+          </a:fillRef>
+          <a:effectRef idx="2">
+            <a:schemeClr val="accent1"/>
+          </a:effectRef>
+          <a:fontRef idx="minor">
+            <a:schemeClr val="lt1"/>
+          </a:fontRef>
+        </p:style>
+        <p:txBody>
+          <a:bodyPr rtlCol="0" anchor="ctr" wrap="none"/>
+          <a:lstStyle/>
+          <a:p>
+            <a:pPr algn="ctr"/>
+          </a:p>
+        </p:txBody>
+      </p:sp>
+      <p:sp>
+        <p:nvSpPr>
+          <p:cNvPr id="23" name="TextBox 22"/>
+          <p:cNvSpPr txBox="1"/>
+          <p:nvPr/>
+        </p:nvSpPr>
+        <p:spPr>
+          <a:xfrm>
+            <a:off x="3464744" y="862148"/>
+            <a:ext cx="1064029" cy="313508"/>
+          </a:xfrm>
+          <a:prstGeom prst="rect">
+            <a:avLst/>
+          </a:prstGeom>
+          <a:noFill/>
+        </p:spPr>
+        <p:txBody>
+          <a:bodyPr wrap="square">
+            <a:spAutoFit/>
+          </a:bodyPr>
+          <a:lstStyle/>
+          <a:p>
+            <a:pPr algn="ctr"/>
+            <a:r>
+              <a:rPr sz="800" b="0">
+                <a:solidFill>
+                  <a:srgbClr val="212121"/>
+                </a:solidFill>
+              </a:rPr>
+              <a:t>RMSNorm + Linear
+d=256</a:t>
+            </a:r>
+          </a:p>
+        </p:txBody>
+      </p:sp>
+      <p:sp>
+        <p:nvSpPr>
+          <p:cNvPr id="24" name="Rounded Rectangle 23"/>
+          <p:cNvSpPr/>
+          <p:nvPr/>
+        </p:nvSpPr>
+        <p:spPr>
+          <a:xfrm>
+            <a:off x="7288599" y="564315"/>
+            <a:ext cx="4116462" cy="7061780"/>
+          </a:xfrm>
+          <a:prstGeom prst="roundRect">
+            <a:avLst>
+              <a:gd name="adj" fmla="val 4000"/>
+            </a:avLst>
+          </a:prstGeom>
+          <a:solidFill>
+            <a:srgbClr val="0D47A1"/>
+          </a:solidFill>
+          <a:ln w="25400">
+            <a:solidFill>
+              <a:srgbClr val="7986CB"/>
+            </a:solidFill>
+          </a:ln>
+        </p:spPr>
+        <p:style>
+          <a:lnRef idx="1">
+            <a:schemeClr val="accent1"/>
+          </a:lnRef>
+          <a:fillRef idx="3">
+            <a:schemeClr val="accent1"/>
+          </a:fillRef>
+          <a:effectRef idx="2">
+            <a:schemeClr val="accent1"/>
+          </a:effectRef>
+          <a:fontRef idx="minor">
+            <a:schemeClr val="lt1"/>
+          </a:fontRef>
+        </p:style>
+        <p:txBody>
+          <a:bodyPr rtlCol="0" anchor="ctr" wrap="none"/>
+          <a:lstStyle/>
+          <a:p>
+            <a:pPr algn="ctr"/>
+          </a:p>
+        </p:txBody>
+      </p:sp>
+      <p:sp>
+        <p:nvSpPr>
+          <p:cNvPr id="25" name="Rounded Rectangle 24"/>
+          <p:cNvSpPr/>
+          <p:nvPr/>
+        </p:nvSpPr>
+        <p:spPr>
+          <a:xfrm>
+            <a:off x="7355101" y="642692"/>
+            <a:ext cx="3983458" cy="642692"/>
           </a:xfrm>
           <a:prstGeom prst="roundRect">
             <a:avLst>
@@ -4852,26 +4416,92 @@
           <a:p>
             <a:pPr algn="ctr"/>
             <a:r>
-              <a:rPr sz="1000" b="1">
-                <a:solidFill>
-                  <a:srgbClr val="C5CAE9"/>
+              <a:rPr sz="1150" b="1">
+                <a:solidFill>
+                  <a:srgbClr val="FFFFFF"/>
                 </a:solidFill>
               </a:rPr>
-              <a:t>[ t_ins  |  t_act  |  t_emb  |  V_patches  |  h₁ … h₄  |  CLS ]</a:t>
-            </a:r>
-          </a:p>
-        </p:txBody>
-      </p:sp>
-      <p:sp>
-        <p:nvSpPr>
-          <p:cNvPr id="37" name="Rounded Rectangle 36"/>
+              <a:t>LLaMA Fusion Transformer</a:t>
+            </a:r>
+          </a:p>
+          <a:p>
+            <a:pPr algn="ctr"/>
+            <a:r>
+              <a:rPr sz="750" b="0">
+                <a:solidFill>
+                  <a:srgbClr val="FFFFFF"/>
+                </a:solidFill>
+              </a:rPr>
+              <a:t>6 Layers · 8 Heads · d=256 · d_ff=1024 · RMSNorm·RoPE·SwiGLU</a:t>
+            </a:r>
+          </a:p>
+        </p:txBody>
+      </p:sp>
+      <p:sp>
+        <p:nvSpPr>
+          <p:cNvPr id="26" name="Rounded Rectangle 25"/>
           <p:cNvSpPr/>
           <p:nvPr/>
         </p:nvSpPr>
         <p:spPr>
           <a:xfrm>
-            <a:off x="365760" y="4663440"/>
-            <a:ext cx="1642872" cy="301752"/>
+            <a:off x="7355101" y="1379437"/>
+            <a:ext cx="3983458" cy="360534"/>
+          </a:xfrm>
+          <a:prstGeom prst="roundRect">
+            <a:avLst>
+              <a:gd name="adj" fmla="val 4000"/>
+            </a:avLst>
+          </a:prstGeom>
+          <a:solidFill>
+            <a:srgbClr val="0D47A1"/>
+          </a:solidFill>
+          <a:ln w="25400">
+            <a:solidFill>
+              <a:srgbClr val="F9A825"/>
+            </a:solidFill>
+          </a:ln>
+        </p:spPr>
+        <p:style>
+          <a:lnRef idx="1">
+            <a:schemeClr val="accent1"/>
+          </a:lnRef>
+          <a:fillRef idx="3">
+            <a:schemeClr val="accent1"/>
+          </a:fillRef>
+          <a:effectRef idx="2">
+            <a:schemeClr val="accent1"/>
+          </a:effectRef>
+          <a:fontRef idx="minor">
+            <a:schemeClr val="lt1"/>
+          </a:fontRef>
+        </p:style>
+        <p:txBody>
+          <a:bodyPr rtlCol="0" anchor="ctr" wrap="none"/>
+          <a:lstStyle/>
+          <a:p>
+            <a:pPr algn="ctr"/>
+            <a:r>
+              <a:rPr sz="900" b="1">
+                <a:solidFill>
+                  <a:srgbClr val="F9A825"/>
+                </a:solidFill>
+              </a:rPr>
+              <a:t>◈  BIDIRECTIONAL — Full Cross-Stream Attention — No Causal Mask  ◈</a:t>
+            </a:r>
+          </a:p>
+        </p:txBody>
+      </p:sp>
+      <p:sp>
+        <p:nvSpPr>
+          <p:cNvPr id="27" name="Rounded Rectangle 26"/>
+          <p:cNvSpPr/>
+          <p:nvPr/>
+        </p:nvSpPr>
+        <p:spPr>
+          <a:xfrm>
+            <a:off x="7388352" y="7093131"/>
+            <a:ext cx="639525" cy="391885"/>
           </a:xfrm>
           <a:prstGeom prst="roundRect">
             <a:avLst>
@@ -4881,10 +4511,8 @@
           <a:solidFill>
             <a:srgbClr val="1565C0"/>
           </a:solidFill>
-          <a:ln w="10160">
-            <a:solidFill>
-              <a:srgbClr val="90CAF9"/>
-            </a:solidFill>
+          <a:ln>
+            <a:noFill/>
           </a:ln>
         </p:spPr>
         <p:style>
@@ -4909,24 +4537,24 @@
             <a:r>
               <a:rPr sz="800" b="1">
                 <a:solidFill>
-                  <a:srgbClr val="FFFFFF"/>
+                  <a:srgbClr val="E3F2FD"/>
                 </a:solidFill>
               </a:rPr>
-              <a:t>Layer 1</a:t>
-            </a:r>
-          </a:p>
-        </p:txBody>
-      </p:sp>
-      <p:sp>
-        <p:nvSpPr>
-          <p:cNvPr id="38" name="Rounded Rectangle 37"/>
+              <a:t>L1</a:t>
+            </a:r>
+          </a:p>
+        </p:txBody>
+      </p:sp>
+      <p:sp>
+        <p:nvSpPr>
+          <p:cNvPr id="28" name="Rounded Rectangle 27"/>
           <p:cNvSpPr/>
           <p:nvPr/>
         </p:nvSpPr>
         <p:spPr>
           <a:xfrm>
-            <a:off x="2026920" y="4325112"/>
-            <a:ext cx="1642872" cy="301752"/>
+            <a:off x="8054478" y="7093131"/>
+            <a:ext cx="639525" cy="391885"/>
           </a:xfrm>
           <a:prstGeom prst="roundRect">
             <a:avLst>
@@ -4936,10 +4564,8 @@
           <a:solidFill>
             <a:srgbClr val="1976D2"/>
           </a:solidFill>
-          <a:ln w="10160">
-            <a:solidFill>
-              <a:srgbClr val="90CAF9"/>
-            </a:solidFill>
+          <a:ln>
+            <a:noFill/>
           </a:ln>
         </p:spPr>
         <p:style>
@@ -4964,24 +4590,24 @@
             <a:r>
               <a:rPr sz="800" b="1">
                 <a:solidFill>
-                  <a:srgbClr val="FFFFFF"/>
+                  <a:srgbClr val="E3F2FD"/>
                 </a:solidFill>
               </a:rPr>
-              <a:t>Layer 2</a:t>
-            </a:r>
-          </a:p>
-        </p:txBody>
-      </p:sp>
-      <p:sp>
-        <p:nvSpPr>
-          <p:cNvPr id="39" name="Rounded Rectangle 38"/>
+              <a:t>L2</a:t>
+            </a:r>
+          </a:p>
+        </p:txBody>
+      </p:sp>
+      <p:sp>
+        <p:nvSpPr>
+          <p:cNvPr id="29" name="Rounded Rectangle 28"/>
           <p:cNvSpPr/>
           <p:nvPr/>
         </p:nvSpPr>
         <p:spPr>
           <a:xfrm>
-            <a:off x="3688080" y="3986783"/>
-            <a:ext cx="1642872" cy="301752"/>
+            <a:off x="8720605" y="7093131"/>
+            <a:ext cx="639525" cy="391885"/>
           </a:xfrm>
           <a:prstGeom prst="roundRect">
             <a:avLst>
@@ -4991,10 +4617,8 @@
           <a:solidFill>
             <a:srgbClr val="1565C0"/>
           </a:solidFill>
-          <a:ln w="10160">
-            <a:solidFill>
-              <a:srgbClr val="90CAF9"/>
-            </a:solidFill>
+          <a:ln>
+            <a:noFill/>
           </a:ln>
         </p:spPr>
         <p:style>
@@ -5019,24 +4643,24 @@
             <a:r>
               <a:rPr sz="800" b="1">
                 <a:solidFill>
-                  <a:srgbClr val="FFFFFF"/>
+                  <a:srgbClr val="E3F2FD"/>
                 </a:solidFill>
               </a:rPr>
-              <a:t>Layer 3</a:t>
-            </a:r>
-          </a:p>
-        </p:txBody>
-      </p:sp>
-      <p:sp>
-        <p:nvSpPr>
-          <p:cNvPr id="40" name="Rounded Rectangle 39"/>
+              <a:t>L3</a:t>
+            </a:r>
+          </a:p>
+        </p:txBody>
+      </p:sp>
+      <p:sp>
+        <p:nvSpPr>
+          <p:cNvPr id="30" name="Rounded Rectangle 29"/>
           <p:cNvSpPr/>
           <p:nvPr/>
         </p:nvSpPr>
         <p:spPr>
           <a:xfrm>
-            <a:off x="5349240" y="3648455"/>
-            <a:ext cx="1642872" cy="301752"/>
+            <a:off x="9386731" y="7093131"/>
+            <a:ext cx="639525" cy="391885"/>
           </a:xfrm>
           <a:prstGeom prst="roundRect">
             <a:avLst>
@@ -5046,10 +4670,8 @@
           <a:solidFill>
             <a:srgbClr val="1976D2"/>
           </a:solidFill>
-          <a:ln w="10160">
-            <a:solidFill>
-              <a:srgbClr val="90CAF9"/>
-            </a:solidFill>
+          <a:ln>
+            <a:noFill/>
           </a:ln>
         </p:spPr>
         <p:style>
@@ -5074,24 +4696,24 @@
             <a:r>
               <a:rPr sz="800" b="1">
                 <a:solidFill>
-                  <a:srgbClr val="FFFFFF"/>
+                  <a:srgbClr val="E3F2FD"/>
                 </a:solidFill>
               </a:rPr>
-              <a:t>Layer 4</a:t>
-            </a:r>
-          </a:p>
-        </p:txBody>
-      </p:sp>
-      <p:sp>
-        <p:nvSpPr>
-          <p:cNvPr id="41" name="Rounded Rectangle 40"/>
+              <a:t>L4</a:t>
+            </a:r>
+          </a:p>
+        </p:txBody>
+      </p:sp>
+      <p:sp>
+        <p:nvSpPr>
+          <p:cNvPr id="31" name="Rounded Rectangle 30"/>
           <p:cNvSpPr/>
           <p:nvPr/>
         </p:nvSpPr>
         <p:spPr>
           <a:xfrm>
-            <a:off x="7010400" y="3310127"/>
-            <a:ext cx="1642872" cy="301752"/>
+            <a:off x="10052858" y="7093131"/>
+            <a:ext cx="639525" cy="391885"/>
           </a:xfrm>
           <a:prstGeom prst="roundRect">
             <a:avLst>
@@ -5101,10 +4723,8 @@
           <a:solidFill>
             <a:srgbClr val="1565C0"/>
           </a:solidFill>
-          <a:ln w="10160">
-            <a:solidFill>
-              <a:srgbClr val="90CAF9"/>
-            </a:solidFill>
+          <a:ln>
+            <a:noFill/>
           </a:ln>
         </p:spPr>
         <p:style>
@@ -5129,24 +4749,24 @@
             <a:r>
               <a:rPr sz="800" b="1">
                 <a:solidFill>
-                  <a:srgbClr val="FFFFFF"/>
+                  <a:srgbClr val="E3F2FD"/>
                 </a:solidFill>
               </a:rPr>
-              <a:t>Layer 5</a:t>
-            </a:r>
-          </a:p>
-        </p:txBody>
-      </p:sp>
-      <p:sp>
-        <p:nvSpPr>
-          <p:cNvPr id="42" name="Rounded Rectangle 41"/>
+              <a:t>L5</a:t>
+            </a:r>
+          </a:p>
+        </p:txBody>
+      </p:sp>
+      <p:sp>
+        <p:nvSpPr>
+          <p:cNvPr id="32" name="Rounded Rectangle 31"/>
           <p:cNvSpPr/>
           <p:nvPr/>
         </p:nvSpPr>
         <p:spPr>
           <a:xfrm>
-            <a:off x="8671560" y="2971799"/>
-            <a:ext cx="1642872" cy="301752"/>
+            <a:off x="10718984" y="7093131"/>
+            <a:ext cx="639525" cy="391885"/>
           </a:xfrm>
           <a:prstGeom prst="roundRect">
             <a:avLst>
@@ -5156,10 +4776,8 @@
           <a:solidFill>
             <a:srgbClr val="1976D2"/>
           </a:solidFill>
-          <a:ln w="10160">
-            <a:solidFill>
-              <a:srgbClr val="90CAF9"/>
-            </a:solidFill>
+          <a:ln>
+            <a:noFill/>
           </a:ln>
         </p:spPr>
         <p:style>
@@ -5184,14 +4802,471 @@
             <a:r>
               <a:rPr sz="800" b="1">
                 <a:solidFill>
+                  <a:srgbClr val="E3F2FD"/>
+                </a:solidFill>
+              </a:rPr>
+              <a:t>L6</a:t>
+            </a:r>
+          </a:p>
+        </p:txBody>
+      </p:sp>
+      <p:sp>
+        <p:nvSpPr>
+          <p:cNvPr id="33" name="Rounded Rectangle 32"/>
+          <p:cNvSpPr/>
+          <p:nvPr/>
+        </p:nvSpPr>
+        <p:spPr>
+          <a:xfrm>
+            <a:off x="11551365" y="642692"/>
+            <a:ext cx="1330036" cy="2683476"/>
+          </a:xfrm>
+          <a:prstGeom prst="roundRect">
+            <a:avLst>
+              <a:gd name="adj" fmla="val 4000"/>
+            </a:avLst>
+          </a:prstGeom>
+          <a:solidFill>
+            <a:srgbClr val="BF360C"/>
+          </a:solidFill>
+          <a:ln>
+            <a:noFill/>
+          </a:ln>
+        </p:spPr>
+        <p:style>
+          <a:lnRef idx="1">
+            <a:schemeClr val="accent1"/>
+          </a:lnRef>
+          <a:fillRef idx="3">
+            <a:schemeClr val="accent1"/>
+          </a:fillRef>
+          <a:effectRef idx="2">
+            <a:schemeClr val="accent1"/>
+          </a:effectRef>
+          <a:fontRef idx="minor">
+            <a:schemeClr val="lt1"/>
+          </a:fontRef>
+        </p:style>
+        <p:txBody>
+          <a:bodyPr rtlCol="0" anchor="ctr" wrap="none"/>
+          <a:lstStyle/>
+          <a:p>
+            <a:pPr algn="ctr"/>
+            <a:r>
+              <a:rPr sz="950" b="1">
+                <a:solidFill>
                   <a:srgbClr val="FFFFFF"/>
                 </a:solidFill>
               </a:rPr>
-              <a:t>Layer 6</a:t>
-            </a:r>
-          </a:p>
-        </p:txBody>
-      </p:sp>
+              <a:t>Discrete</a:t>
+            </a:r>
+          </a:p>
+          <a:p>
+            <a:pPr algn="ctr"/>
+            <a:r>
+              <a:rPr sz="950" b="1">
+                <a:solidFill>
+                  <a:srgbClr val="FFFFFF"/>
+                </a:solidFill>
+              </a:rPr>
+              <a:t>Action Head</a:t>
+            </a:r>
+          </a:p>
+          <a:p>
+            <a:pPr algn="ctr"/>
+            <a:r>
+              <a:rPr sz="850" b="0">
+                <a:solidFill>
+                  <a:srgbClr val="FFFFFF"/>
+                </a:solidFill>
+              </a:rPr>
+              <a:t>8-bin logits</a:t>
+            </a:r>
+          </a:p>
+          <a:p>
+            <a:pPr algn="ctr"/>
+            <a:r>
+              <a:rPr sz="800" b="0">
+                <a:solidFill>
+                  <a:srgbClr val="FFFFFF"/>
+                </a:solidFill>
+              </a:rPr>
+              <a:t>×K=4 chunks</a:t>
+            </a:r>
+          </a:p>
+        </p:txBody>
+      </p:sp>
+      <p:sp>
+        <p:nvSpPr>
+          <p:cNvPr id="34" name="Rounded Rectangle 33"/>
+          <p:cNvSpPr/>
+          <p:nvPr/>
+        </p:nvSpPr>
+        <p:spPr>
+          <a:xfrm>
+            <a:off x="11551365" y="4864242"/>
+            <a:ext cx="1330036" cy="2683476"/>
+          </a:xfrm>
+          <a:prstGeom prst="roundRect">
+            <a:avLst>
+              <a:gd name="adj" fmla="val 4000"/>
+            </a:avLst>
+          </a:prstGeom>
+          <a:solidFill>
+            <a:srgbClr val="1B5E20"/>
+          </a:solidFill>
+          <a:ln>
+            <a:noFill/>
+          </a:ln>
+        </p:spPr>
+        <p:style>
+          <a:lnRef idx="1">
+            <a:schemeClr val="accent1"/>
+          </a:lnRef>
+          <a:fillRef idx="3">
+            <a:schemeClr val="accent1"/>
+          </a:fillRef>
+          <a:effectRef idx="2">
+            <a:schemeClr val="accent1"/>
+          </a:effectRef>
+          <a:fontRef idx="minor">
+            <a:schemeClr val="lt1"/>
+          </a:fontRef>
+        </p:style>
+        <p:txBody>
+          <a:bodyPr rtlCol="0" anchor="ctr" wrap="none"/>
+          <a:lstStyle/>
+          <a:p>
+            <a:pPr algn="ctr"/>
+            <a:r>
+              <a:rPr sz="950" b="1">
+                <a:solidFill>
+                  <a:srgbClr val="FFFFFF"/>
+                </a:solidFill>
+              </a:rPr>
+              <a:t>Regression</a:t>
+            </a:r>
+          </a:p>
+          <a:p>
+            <a:pPr algn="ctr"/>
+            <a:r>
+              <a:rPr sz="950" b="1">
+                <a:solidFill>
+                  <a:srgbClr val="FFFFFF"/>
+                </a:solidFill>
+              </a:rPr>
+              <a:t>Head</a:t>
+            </a:r>
+          </a:p>
+          <a:p>
+            <a:pPr algn="ctr"/>
+            <a:r>
+              <a:rPr sz="900" b="0">
+                <a:solidFill>
+                  <a:srgbClr val="FFFFFF"/>
+                </a:solidFill>
+              </a:rPr>
+              <a:t>[Δx, Δy]</a:t>
+            </a:r>
+          </a:p>
+        </p:txBody>
+      </p:sp>
+      <p:cxnSp>
+        <p:nvCxnSpPr>
+          <p:cNvPr id="35" name="Connector 34"/>
+          <p:cNvCxnSpPr/>
+          <p:nvPr/>
+        </p:nvCxnSpPr>
+        <p:spPr>
+          <a:xfrm>
+            <a:off x="1908602" y="1332411"/>
+            <a:ext cx="332509" cy="0"/>
+          </a:xfrm>
+          <a:prstGeom prst="line">
+            <a:avLst/>
+          </a:prstGeom>
+          <a:ln w="25400">
+            <a:solidFill>
+              <a:srgbClr val="1565C0"/>
+            </a:solidFill>
+            <a:tailEnd type="none"/>
+            <a:headEnd type="arrow" w="med" len="med"/>
+          </a:ln>
+        </p:spPr>
+        <p:style>
+          <a:lnRef idx="2">
+            <a:schemeClr val="accent1"/>
+          </a:lnRef>
+          <a:fillRef idx="0">
+            <a:schemeClr val="accent1"/>
+          </a:fillRef>
+          <a:effectRef idx="1">
+            <a:schemeClr val="accent1"/>
+          </a:effectRef>
+          <a:fontRef idx="minor">
+            <a:schemeClr val="tx1"/>
+          </a:fontRef>
+        </p:style>
+      </p:cxnSp>
+      <p:cxnSp>
+        <p:nvCxnSpPr>
+          <p:cNvPr id="36" name="Connector 35"/>
+          <p:cNvCxnSpPr/>
+          <p:nvPr/>
+        </p:nvCxnSpPr>
+        <p:spPr>
+          <a:xfrm>
+            <a:off x="3677550" y="1332411"/>
+            <a:ext cx="133004" cy="0"/>
+          </a:xfrm>
+          <a:prstGeom prst="line">
+            <a:avLst/>
+          </a:prstGeom>
+          <a:ln w="22860">
+            <a:solidFill>
+              <a:srgbClr val="1565C0"/>
+            </a:solidFill>
+            <a:tailEnd type="none"/>
+            <a:headEnd type="arrow" w="med" len="med"/>
+          </a:ln>
+        </p:spPr>
+        <p:style>
+          <a:lnRef idx="2">
+            <a:schemeClr val="accent1"/>
+          </a:lnRef>
+          <a:fillRef idx="0">
+            <a:schemeClr val="accent1"/>
+          </a:fillRef>
+          <a:effectRef idx="1">
+            <a:schemeClr val="accent1"/>
+          </a:effectRef>
+          <a:fontRef idx="minor">
+            <a:schemeClr val="tx1"/>
+          </a:fontRef>
+        </p:style>
+      </p:cxnSp>
+      <p:cxnSp>
+        <p:nvCxnSpPr>
+          <p:cNvPr id="37" name="Connector 36"/>
+          <p:cNvCxnSpPr/>
+          <p:nvPr/>
+        </p:nvCxnSpPr>
+        <p:spPr>
+          <a:xfrm>
+            <a:off x="1908602" y="2547257"/>
+            <a:ext cx="332509" cy="0"/>
+          </a:xfrm>
+          <a:prstGeom prst="line">
+            <a:avLst/>
+          </a:prstGeom>
+          <a:ln w="25400">
+            <a:solidFill>
+              <a:srgbClr val="2E7D32"/>
+            </a:solidFill>
+            <a:tailEnd type="none"/>
+            <a:headEnd type="arrow" w="med" len="med"/>
+          </a:ln>
+        </p:spPr>
+        <p:style>
+          <a:lnRef idx="2">
+            <a:schemeClr val="accent1"/>
+          </a:lnRef>
+          <a:fillRef idx="0">
+            <a:schemeClr val="accent1"/>
+          </a:fillRef>
+          <a:effectRef idx="1">
+            <a:schemeClr val="accent1"/>
+          </a:effectRef>
+          <a:fontRef idx="minor">
+            <a:schemeClr val="tx1"/>
+          </a:fontRef>
+        </p:style>
+      </p:cxnSp>
+      <p:cxnSp>
+        <p:nvCxnSpPr>
+          <p:cNvPr id="38" name="Connector 37"/>
+          <p:cNvCxnSpPr/>
+          <p:nvPr/>
+        </p:nvCxnSpPr>
+        <p:spPr>
+          <a:xfrm>
+            <a:off x="3677550" y="2547257"/>
+            <a:ext cx="133004" cy="0"/>
+          </a:xfrm>
+          <a:prstGeom prst="line">
+            <a:avLst/>
+          </a:prstGeom>
+          <a:ln w="22860">
+            <a:solidFill>
+              <a:srgbClr val="2E7D32"/>
+            </a:solidFill>
+            <a:tailEnd type="none"/>
+            <a:headEnd type="arrow" w="med" len="med"/>
+          </a:ln>
+        </p:spPr>
+        <p:style>
+          <a:lnRef idx="2">
+            <a:schemeClr val="accent1"/>
+          </a:lnRef>
+          <a:fillRef idx="0">
+            <a:schemeClr val="accent1"/>
+          </a:fillRef>
+          <a:effectRef idx="1">
+            <a:schemeClr val="accent1"/>
+          </a:effectRef>
+          <a:fontRef idx="minor">
+            <a:schemeClr val="tx1"/>
+          </a:fontRef>
+        </p:style>
+      </p:cxnSp>
+      <p:cxnSp>
+        <p:nvCxnSpPr>
+          <p:cNvPr id="39" name="Connector 38"/>
+          <p:cNvCxnSpPr/>
+          <p:nvPr/>
+        </p:nvCxnSpPr>
+        <p:spPr>
+          <a:xfrm>
+            <a:off x="1908602" y="3762102"/>
+            <a:ext cx="332509" cy="0"/>
+          </a:xfrm>
+          <a:prstGeom prst="line">
+            <a:avLst/>
+          </a:prstGeom>
+          <a:ln w="25400">
+            <a:solidFill>
+              <a:srgbClr val="E65100"/>
+            </a:solidFill>
+            <a:tailEnd type="none"/>
+            <a:headEnd type="arrow" w="med" len="med"/>
+          </a:ln>
+        </p:spPr>
+        <p:style>
+          <a:lnRef idx="2">
+            <a:schemeClr val="accent1"/>
+          </a:lnRef>
+          <a:fillRef idx="0">
+            <a:schemeClr val="accent1"/>
+          </a:fillRef>
+          <a:effectRef idx="1">
+            <a:schemeClr val="accent1"/>
+          </a:effectRef>
+          <a:fontRef idx="minor">
+            <a:schemeClr val="tx1"/>
+          </a:fontRef>
+        </p:style>
+      </p:cxnSp>
+      <p:cxnSp>
+        <p:nvCxnSpPr>
+          <p:cNvPr id="40" name="Connector 39"/>
+          <p:cNvCxnSpPr/>
+          <p:nvPr/>
+        </p:nvCxnSpPr>
+        <p:spPr>
+          <a:xfrm>
+            <a:off x="3677550" y="3762102"/>
+            <a:ext cx="133004" cy="0"/>
+          </a:xfrm>
+          <a:prstGeom prst="line">
+            <a:avLst/>
+          </a:prstGeom>
+          <a:ln w="22860">
+            <a:solidFill>
+              <a:srgbClr val="E65100"/>
+            </a:solidFill>
+            <a:tailEnd type="none"/>
+            <a:headEnd type="arrow" w="med" len="med"/>
+          </a:ln>
+        </p:spPr>
+        <p:style>
+          <a:lnRef idx="2">
+            <a:schemeClr val="accent1"/>
+          </a:lnRef>
+          <a:fillRef idx="0">
+            <a:schemeClr val="accent1"/>
+          </a:fillRef>
+          <a:effectRef idx="1">
+            <a:schemeClr val="accent1"/>
+          </a:effectRef>
+          <a:fontRef idx="minor">
+            <a:schemeClr val="tx1"/>
+          </a:fontRef>
+        </p:style>
+      </p:cxnSp>
+      <p:cxnSp>
+        <p:nvCxnSpPr>
+          <p:cNvPr id="41" name="Connector 40"/>
+          <p:cNvCxnSpPr/>
+          <p:nvPr/>
+        </p:nvCxnSpPr>
+        <p:spPr>
+          <a:xfrm>
+            <a:off x="1908602" y="4976948"/>
+            <a:ext cx="332509" cy="0"/>
+          </a:xfrm>
+          <a:prstGeom prst="line">
+            <a:avLst/>
+          </a:prstGeom>
+          <a:ln w="25400">
+            <a:solidFill>
+              <a:srgbClr val="880E4F"/>
+            </a:solidFill>
+            <a:tailEnd type="none"/>
+            <a:headEnd type="arrow" w="med" len="med"/>
+          </a:ln>
+        </p:spPr>
+        <p:style>
+          <a:lnRef idx="2">
+            <a:schemeClr val="accent1"/>
+          </a:lnRef>
+          <a:fillRef idx="0">
+            <a:schemeClr val="accent1"/>
+          </a:fillRef>
+          <a:effectRef idx="1">
+            <a:schemeClr val="accent1"/>
+          </a:effectRef>
+          <a:fontRef idx="minor">
+            <a:schemeClr val="tx1"/>
+          </a:fontRef>
+        </p:style>
+      </p:cxnSp>
+      <p:cxnSp>
+        <p:nvCxnSpPr>
+          <p:cNvPr id="42" name="Connector 41"/>
+          <p:cNvCxnSpPr/>
+          <p:nvPr/>
+        </p:nvCxnSpPr>
+        <p:spPr>
+          <a:xfrm>
+            <a:off x="3677550" y="4976948"/>
+            <a:ext cx="133004" cy="0"/>
+          </a:xfrm>
+          <a:prstGeom prst="line">
+            <a:avLst/>
+          </a:prstGeom>
+          <a:ln w="22860">
+            <a:solidFill>
+              <a:srgbClr val="880E4F"/>
+            </a:solidFill>
+            <a:tailEnd type="none"/>
+            <a:headEnd type="arrow" w="med" len="med"/>
+          </a:ln>
+        </p:spPr>
+        <p:style>
+          <a:lnRef idx="2">
+            <a:schemeClr val="accent1"/>
+          </a:lnRef>
+          <a:fillRef idx="0">
+            <a:schemeClr val="accent1"/>
+          </a:fillRef>
+          <a:effectRef idx="1">
+            <a:schemeClr val="accent1"/>
+          </a:effectRef>
+          <a:fontRef idx="minor">
+            <a:schemeClr val="tx1"/>
+          </a:fontRef>
+        </p:style>
+      </p:cxnSp>
       <p:cxnSp>
         <p:nvCxnSpPr>
           <p:cNvPr id="43" name="Connector 42"/>
@@ -5199,16 +5274,16 @@
           <p:nvPr/>
         </p:nvCxnSpPr>
         <p:spPr>
-          <a:xfrm flipV="1">
-            <a:off x="5294375" y="2542032"/>
-            <a:ext cx="0" cy="182879"/>
+          <a:xfrm>
+            <a:off x="1908602" y="6191794"/>
+            <a:ext cx="332509" cy="0"/>
           </a:xfrm>
           <a:prstGeom prst="line">
             <a:avLst/>
           </a:prstGeom>
-          <a:ln w="40640">
+          <a:ln w="25400">
             <a:solidFill>
-              <a:srgbClr val="FFD54F"/>
+              <a:srgbClr val="4527A0"/>
             </a:solidFill>
             <a:tailEnd type="none"/>
             <a:headEnd type="arrow" w="med" len="med"/>
@@ -5229,61 +5304,43 @@
           </a:fontRef>
         </p:style>
       </p:cxnSp>
-      <p:sp>
-        <p:nvSpPr>
-          <p:cNvPr id="44" name="Rounded Rectangle 43"/>
-          <p:cNvSpPr/>
+      <p:cxnSp>
+        <p:nvCxnSpPr>
+          <p:cNvPr id="44" name="Connector 43"/>
+          <p:cNvCxnSpPr/>
           <p:nvPr/>
-        </p:nvSpPr>
-        <p:spPr>
-          <a:xfrm>
-            <a:off x="201168" y="2066543"/>
-            <a:ext cx="10186415" cy="475488"/>
-          </a:xfrm>
-          <a:prstGeom prst="roundRect">
-            <a:avLst>
-              <a:gd name="adj" fmla="val 4000"/>
-            </a:avLst>
+        </p:nvCxnSpPr>
+        <p:spPr>
+          <a:xfrm>
+            <a:off x="3677550" y="6191794"/>
+            <a:ext cx="133004" cy="0"/>
+          </a:xfrm>
+          <a:prstGeom prst="line">
+            <a:avLst/>
           </a:prstGeom>
-          <a:solidFill>
-            <a:srgbClr val="0D47A1"/>
-          </a:solidFill>
-          <a:ln w="35560">
+          <a:ln w="22860">
             <a:solidFill>
-              <a:srgbClr val="FFD54F"/>
+              <a:srgbClr val="4527A0"/>
             </a:solidFill>
+            <a:tailEnd type="none"/>
+            <a:headEnd type="arrow" w="med" len="med"/>
           </a:ln>
         </p:spPr>
         <p:style>
-          <a:lnRef idx="1">
+          <a:lnRef idx="2">
             <a:schemeClr val="accent1"/>
           </a:lnRef>
-          <a:fillRef idx="3">
+          <a:fillRef idx="0">
             <a:schemeClr val="accent1"/>
           </a:fillRef>
-          <a:effectRef idx="2">
+          <a:effectRef idx="1">
             <a:schemeClr val="accent1"/>
           </a:effectRef>
           <a:fontRef idx="minor">
-            <a:schemeClr val="lt1"/>
+            <a:schemeClr val="tx1"/>
           </a:fontRef>
         </p:style>
-        <p:txBody>
-          <a:bodyPr rtlCol="0" anchor="ctr" wrap="none"/>
-          <a:lstStyle/>
-          <a:p>
-            <a:pPr algn="ctr"/>
-            <a:r>
-              <a:rPr sz="1300" b="1">
-                <a:solidFill>
-                  <a:srgbClr val="FFFFFF"/>
-                </a:solidFill>
-              </a:rPr>
-              <a:t>CLS  →  Policy Head Input</a:t>
-            </a:r>
-          </a:p>
-        </p:txBody>
-      </p:sp>
+      </p:cxnSp>
       <p:cxnSp>
         <p:nvCxnSpPr>
           <p:cNvPr id="45" name="Connector 44"/>
@@ -5291,16 +5348,16 @@
           <p:nvPr/>
         </p:nvCxnSpPr>
         <p:spPr>
-          <a:xfrm flipH="1" flipV="1">
-            <a:off x="2702052" y="1883664"/>
-            <a:ext cx="2592323" cy="182879"/>
+          <a:xfrm>
+            <a:off x="3863755" y="3762102"/>
+            <a:ext cx="266007" cy="0"/>
           </a:xfrm>
           <a:prstGeom prst="line">
             <a:avLst/>
           </a:prstGeom>
-          <a:ln w="31750">
+          <a:ln w="27940">
             <a:solidFill>
-              <a:srgbClr val="BBDEFB"/>
+              <a:srgbClr val="78909C"/>
             </a:solidFill>
             <a:tailEnd type="none"/>
             <a:headEnd type="arrow" w="med" len="med"/>
@@ -5328,16 +5385,16 @@
           <p:nvPr/>
         </p:nvCxnSpPr>
         <p:spPr>
-          <a:xfrm flipV="1">
-            <a:off x="5294375" y="1883664"/>
-            <a:ext cx="2592325" cy="182879"/>
+          <a:xfrm>
+            <a:off x="7055842" y="3762102"/>
+            <a:ext cx="232757" cy="0"/>
           </a:xfrm>
           <a:prstGeom prst="line">
             <a:avLst/>
           </a:prstGeom>
-          <a:ln w="31750">
+          <a:ln w="35560">
             <a:solidFill>
-              <a:srgbClr val="BBDEFB"/>
+              <a:srgbClr val="F9A825"/>
             </a:solidFill>
             <a:tailEnd type="none"/>
             <a:headEnd type="arrow" w="med" len="med"/>
@@ -5358,16 +5415,127 @@
           </a:fontRef>
         </p:style>
       </p:cxnSp>
-      <p:sp>
-        <p:nvSpPr>
-          <p:cNvPr id="47" name="Rounded Rectangle 46"/>
+      <p:cxnSp>
+        <p:nvCxnSpPr>
+          <p:cNvPr id="47" name="Connector 46"/>
+          <p:cNvCxnSpPr/>
+          <p:nvPr/>
+        </p:nvCxnSpPr>
+        <p:spPr>
+          <a:xfrm>
+            <a:off x="11405061" y="4095205"/>
+            <a:ext cx="146304" cy="0"/>
+          </a:xfrm>
+          <a:prstGeom prst="line">
+            <a:avLst/>
+          </a:prstGeom>
+          <a:ln w="31750">
+            <a:solidFill>
+              <a:srgbClr val="F9A825"/>
+            </a:solidFill>
+            <a:tailEnd type="none"/>
+            <a:headEnd type="arrow" w="med" len="med"/>
+          </a:ln>
+        </p:spPr>
+        <p:style>
+          <a:lnRef idx="2">
+            <a:schemeClr val="accent1"/>
+          </a:lnRef>
+          <a:fillRef idx="0">
+            <a:schemeClr val="accent1"/>
+          </a:fillRef>
+          <a:effectRef idx="1">
+            <a:schemeClr val="accent1"/>
+          </a:effectRef>
+          <a:fontRef idx="minor">
+            <a:schemeClr val="tx1"/>
+          </a:fontRef>
+        </p:style>
+      </p:cxnSp>
+      <p:cxnSp>
+        <p:nvCxnSpPr>
+          <p:cNvPr id="48" name="Connector 47"/>
+          <p:cNvCxnSpPr/>
+          <p:nvPr/>
+        </p:nvCxnSpPr>
+        <p:spPr>
+          <a:xfrm>
+            <a:off x="12881402" y="1984430"/>
+            <a:ext cx="266007" cy="0"/>
+          </a:xfrm>
+          <a:prstGeom prst="line">
+            <a:avLst/>
+          </a:prstGeom>
+          <a:ln w="25400">
+            <a:solidFill>
+              <a:srgbClr val="FFCCBC"/>
+            </a:solidFill>
+            <a:tailEnd type="none"/>
+            <a:headEnd type="arrow" w="med" len="med"/>
+          </a:ln>
+        </p:spPr>
+        <p:style>
+          <a:lnRef idx="2">
+            <a:schemeClr val="accent1"/>
+          </a:lnRef>
+          <a:fillRef idx="0">
+            <a:schemeClr val="accent1"/>
+          </a:fillRef>
+          <a:effectRef idx="1">
+            <a:schemeClr val="accent1"/>
+          </a:effectRef>
+          <a:fontRef idx="minor">
+            <a:schemeClr val="tx1"/>
+          </a:fontRef>
+        </p:style>
+      </p:cxnSp>
+      <p:cxnSp>
+        <p:nvCxnSpPr>
+          <p:cNvPr id="49" name="Connector 48"/>
+          <p:cNvCxnSpPr/>
+          <p:nvPr/>
+        </p:nvCxnSpPr>
+        <p:spPr>
+          <a:xfrm>
+            <a:off x="12881402" y="6205980"/>
+            <a:ext cx="266007" cy="0"/>
+          </a:xfrm>
+          <a:prstGeom prst="line">
+            <a:avLst/>
+          </a:prstGeom>
+          <a:ln w="25400">
+            <a:solidFill>
+              <a:srgbClr val="C8E6C9"/>
+            </a:solidFill>
+            <a:tailEnd type="none"/>
+            <a:headEnd type="arrow" w="med" len="med"/>
+          </a:ln>
+        </p:spPr>
+        <p:style>
+          <a:lnRef idx="2">
+            <a:schemeClr val="accent1"/>
+          </a:lnRef>
+          <a:fillRef idx="0">
+            <a:schemeClr val="accent1"/>
+          </a:fillRef>
+          <a:effectRef idx="1">
+            <a:schemeClr val="accent1"/>
+          </a:effectRef>
+          <a:fontRef idx="minor">
+            <a:schemeClr val="tx1"/>
+          </a:fontRef>
+        </p:style>
+      </p:cxnSp>
+      <p:sp>
+        <p:nvSpPr>
+          <p:cNvPr id="50" name="Rounded Rectangle 49"/>
           <p:cNvSpPr/>
           <p:nvPr/>
         </p:nvSpPr>
         <p:spPr>
           <a:xfrm>
-            <a:off x="201168" y="859536"/>
-            <a:ext cx="5001768" cy="1024128"/>
+            <a:off x="13147409" y="642692"/>
+            <a:ext cx="1363287" cy="2683476"/>
           </a:xfrm>
           <a:prstGeom prst="roundRect">
             <a:avLst>
@@ -5401,48 +5569,48 @@
           <a:p>
             <a:pPr algn="ctr"/>
             <a:r>
-              <a:rPr sz="1200" b="1">
+              <a:rPr sz="900" b="1">
                 <a:solidFill>
                   <a:srgbClr val="FFFFFF"/>
                 </a:solidFill>
               </a:rPr>
-              <a:t>Discrete Action Head</a:t>
+              <a:t>Discrete Action</a:t>
             </a:r>
           </a:p>
           <a:p>
             <a:pPr algn="ctr"/>
             <a:r>
-              <a:rPr sz="950" b="0">
+              <a:rPr sz="900" b="0">
                 <a:solidFill>
                   <a:srgbClr val="FFFFFF"/>
                 </a:solidFill>
               </a:rPr>
-              <a:t>Expand-Compress → FC</a:t>
+              <a:t>8-bin × K=4</a:t>
             </a:r>
           </a:p>
           <a:p>
             <a:pPr algn="ctr"/>
             <a:r>
-              <a:rPr sz="950" b="0">
+              <a:rPr sz="750" b="0">
                 <a:solidFill>
                   <a:srgbClr val="FFFFFF"/>
                 </a:solidFill>
               </a:rPr>
-              <a:t>8-bin logits  ×  K = 4 chunks  (π₀ style)</a:t>
-            </a:r>
-          </a:p>
-        </p:txBody>
-      </p:sp>
-      <p:sp>
-        <p:nvSpPr>
-          <p:cNvPr id="48" name="Rounded Rectangle 47"/>
+              <a:t>(π₀ style)</a:t>
+            </a:r>
+          </a:p>
+        </p:txBody>
+      </p:sp>
+      <p:sp>
+        <p:nvSpPr>
+          <p:cNvPr id="51" name="Rounded Rectangle 50"/>
           <p:cNvSpPr/>
           <p:nvPr/>
         </p:nvSpPr>
         <p:spPr>
           <a:xfrm>
-            <a:off x="5385816" y="859536"/>
-            <a:ext cx="5001768" cy="1024128"/>
+            <a:off x="13147409" y="4864242"/>
+            <a:ext cx="1363287" cy="2683476"/>
           </a:xfrm>
           <a:prstGeom prst="roundRect">
             <a:avLst>
@@ -5476,12 +5644,12 @@
           <a:p>
             <a:pPr algn="ctr"/>
             <a:r>
-              <a:rPr sz="1200" b="1">
+              <a:rPr sz="900" b="1">
                 <a:solidFill>
                   <a:srgbClr val="FFFFFF"/>
                 </a:solidFill>
               </a:rPr>
-              <a:t>Continuous Regression Head</a:t>
+              <a:t>Continuous</a:t>
             </a:r>
           </a:p>
           <a:p>
@@ -5492,377 +5660,32 @@
                   <a:srgbClr val="FFFFFF"/>
                 </a:solidFill>
               </a:rPr>
-              <a:t>RMSNorm  +  Tanh</a:t>
+              <a:t>[Δx, Δy]</a:t>
             </a:r>
           </a:p>
           <a:p>
             <a:pPr algn="ctr"/>
             <a:r>
-              <a:rPr sz="950" b="0">
+              <a:rPr sz="800" b="0">
                 <a:solidFill>
                   <a:srgbClr val="FFFFFF"/>
                 </a:solidFill>
               </a:rPr>
-              <a:t>Continuous action  [Δx,  Δy]   (action_dim = 2)</a:t>
-            </a:r>
-          </a:p>
-        </p:txBody>
-      </p:sp>
-      <p:sp>
-        <p:nvSpPr>
-          <p:cNvPr id="49" name="Rounded Rectangle 48"/>
-          <p:cNvSpPr/>
-          <p:nvPr/>
-        </p:nvSpPr>
-        <p:spPr>
-          <a:xfrm>
-            <a:off x="10588752" y="859536"/>
-            <a:ext cx="3840480" cy="6995160"/>
-          </a:xfrm>
-          <a:prstGeom prst="roundRect">
-            <a:avLst>
-              <a:gd name="adj" fmla="val 4000"/>
-            </a:avLst>
-          </a:prstGeom>
-          <a:solidFill>
-            <a:srgbClr val="F57F17"/>
-          </a:solidFill>
-          <a:ln w="25400">
-            <a:solidFill>
-              <a:srgbClr val="FFFFFF"/>
-            </a:solidFill>
-          </a:ln>
-        </p:spPr>
-        <p:style>
-          <a:lnRef idx="1">
-            <a:schemeClr val="accent1"/>
-          </a:lnRef>
-          <a:fillRef idx="3">
-            <a:schemeClr val="accent1"/>
-          </a:fillRef>
-          <a:effectRef idx="2">
-            <a:schemeClr val="accent1"/>
-          </a:effectRef>
-          <a:fontRef idx="minor">
-            <a:schemeClr val="lt1"/>
-          </a:fontRef>
-        </p:style>
-        <p:txBody>
-          <a:bodyPr rtlCol="0" anchor="ctr" wrap="none"/>
-          <a:lstStyle/>
-          <a:p>
-            <a:pPr algn="ctr"/>
-            <a:r>
-              <a:rPr sz="1300" b="1">
-                <a:solidFill>
-                  <a:srgbClr val="FFFFFF"/>
-                </a:solidFill>
-              </a:rPr>
-              <a:t>InfoNCE Alignment Loss</a:t>
-            </a:r>
-          </a:p>
-          <a:p>
-            <a:pPr algn="ctr"/>
-            <a:r>
-              <a:rPr sz="900" b="0">
-                <a:solidFill>
-                  <a:srgbClr val="FFFFFF"/>
-                </a:solidFill>
-              </a:rPr>
-              <a:t>(training only)</a:t>
-            </a:r>
-          </a:p>
-          <a:p>
-            <a:pPr algn="ctr"/>
-            <a:r>
-              <a:rPr sz="500" b="0">
-                <a:solidFill>
-                  <a:srgbClr val="FFFFFF"/>
-                </a:solidFill>
-              </a:rPr>
-              <a:t/>
-            </a:r>
-          </a:p>
-          <a:p>
-            <a:pPr algn="ctr"/>
-            <a:r>
-              <a:rPr sz="1050" b="0">
-                <a:solidFill>
-                  <a:srgbClr val="FFFFFF"/>
-                </a:solidFill>
-              </a:rPr>
-              <a:t>InfoNCE( t_emb, t_act ‖ t_ins )</a:t>
-            </a:r>
-          </a:p>
-          <a:p>
-            <a:pPr algn="ctr"/>
-            <a:r>
-              <a:rPr sz="950" b="0">
-                <a:solidFill>
-                  <a:srgbClr val="FFFFFF"/>
-                </a:solidFill>
-              </a:rPr>
-              <a:t>reward-weighted · exp(5 · r̃)</a:t>
-            </a:r>
-          </a:p>
-          <a:p>
-            <a:pPr algn="ctr"/>
-            <a:r>
-              <a:rPr sz="500" b="0">
-                <a:solidFill>
-                  <a:srgbClr val="FFFFFF"/>
-                </a:solidFill>
-              </a:rPr>
-              <a:t/>
-            </a:r>
-          </a:p>
-          <a:p>
-            <a:pPr algn="ctr"/>
-            <a:r>
-              <a:rPr sz="1500" b="1">
-                <a:solidFill>
-                  <a:srgbClr val="FFFFFF"/>
-                </a:solidFill>
-              </a:rPr>
-              <a:t>λ_align = 0.10</a:t>
-            </a:r>
-          </a:p>
-          <a:p>
-            <a:pPr algn="ctr"/>
-            <a:r>
-              <a:rPr sz="500" b="0">
-                <a:solidFill>
-                  <a:srgbClr val="FFFFFF"/>
-                </a:solidFill>
-              </a:rPr>
-              <a:t/>
-            </a:r>
-          </a:p>
-          <a:p>
-            <a:pPr algn="ctr"/>
-            <a:r>
-              <a:rPr sz="950" b="0">
-                <a:solidFill>
-                  <a:srgbClr val="FFFFFF"/>
-                </a:solidFill>
-              </a:rPr>
-              <a:t>Aligns consequence +</a:t>
-            </a:r>
-          </a:p>
-          <a:p>
-            <a:pPr algn="ctr"/>
-            <a:r>
-              <a:rPr sz="950" b="0">
-                <a:solidFill>
-                  <a:srgbClr val="FFFFFF"/>
-                </a:solidFill>
-              </a:rPr>
-              <a:t>action tokens toward</a:t>
-            </a:r>
-          </a:p>
-          <a:p>
-            <a:pPr algn="ctr"/>
-            <a:r>
-              <a:rPr sz="950" b="0">
-                <a:solidFill>
-                  <a:srgbClr val="FFFFFF"/>
-                </a:solidFill>
-              </a:rPr>
-              <a:t>the task instruction</a:t>
-            </a:r>
-          </a:p>
-          <a:p>
-            <a:pPr algn="ctr"/>
-            <a:r>
-              <a:rPr sz="950" b="0">
-                <a:solidFill>
-                  <a:srgbClr val="FFFFFF"/>
-                </a:solidFill>
-              </a:rPr>
-              <a:t>embedding</a:t>
-            </a:r>
-          </a:p>
-        </p:txBody>
-      </p:sp>
-      <p:sp>
-        <p:nvSpPr>
-          <p:cNvPr id="50" name="Rounded Rectangle 49"/>
-          <p:cNvSpPr/>
-          <p:nvPr/>
-        </p:nvSpPr>
-        <p:spPr>
-          <a:xfrm>
-            <a:off x="10588752" y="7946136"/>
-            <a:ext cx="3840480" cy="-237743"/>
-          </a:xfrm>
-          <a:prstGeom prst="roundRect">
-            <a:avLst>
-              <a:gd name="adj" fmla="val 4000"/>
-            </a:avLst>
-          </a:prstGeom>
-          <a:solidFill>
-            <a:srgbClr val="ECEFF1"/>
-          </a:solidFill>
-          <a:ln w="15240">
-            <a:solidFill>
-              <a:srgbClr val="90A4AE"/>
-            </a:solidFill>
-          </a:ln>
-        </p:spPr>
-        <p:style>
-          <a:lnRef idx="1">
-            <a:schemeClr val="accent1"/>
-          </a:lnRef>
-          <a:fillRef idx="3">
-            <a:schemeClr val="accent1"/>
-          </a:fillRef>
-          <a:effectRef idx="2">
-            <a:schemeClr val="accent1"/>
-          </a:effectRef>
-          <a:fontRef idx="minor">
-            <a:schemeClr val="lt1"/>
-          </a:fontRef>
-        </p:style>
-        <p:txBody>
-          <a:bodyPr rtlCol="0" anchor="ctr" wrap="none"/>
-          <a:lstStyle/>
-          <a:p>
-            <a:pPr algn="ctr"/>
-            <a:r>
-              <a:rPr sz="1000" b="1">
-                <a:solidFill>
-                  <a:srgbClr val="1C1C1C"/>
-                </a:solidFill>
-              </a:rPr>
-              <a:t>⟲  Closed-loop feedback:</a:t>
-            </a:r>
-          </a:p>
-          <a:p>
-            <a:pPr algn="ctr"/>
-            <a:r>
-              <a:rPr sz="900" b="0">
-                <a:solidFill>
-                  <a:srgbClr val="1C1C1C"/>
-                </a:solidFill>
-              </a:rPr>
-              <a:t>action + consequence re-injected</a:t>
-            </a:r>
-          </a:p>
-          <a:p>
-            <a:pPr algn="ctr"/>
-            <a:r>
-              <a:rPr sz="900" b="0">
-                <a:solidFill>
-                  <a:srgbClr val="1C1C1C"/>
-                </a:solidFill>
-              </a:rPr>
-              <a:t>as stream inputs at  t+1</a:t>
-            </a:r>
-          </a:p>
-        </p:txBody>
-      </p:sp>
-      <p:sp>
-        <p:nvSpPr>
-          <p:cNvPr id="51" name="Rounded Rectangle 50"/>
-          <p:cNvSpPr/>
-          <p:nvPr/>
-        </p:nvSpPr>
-        <p:spPr>
-          <a:xfrm>
-            <a:off x="201168" y="8083296"/>
-            <a:ext cx="14228064" cy="384048"/>
-          </a:xfrm>
-          <a:prstGeom prst="roundRect">
-            <a:avLst>
-              <a:gd name="adj" fmla="val 4000"/>
-            </a:avLst>
-          </a:prstGeom>
-          <a:solidFill>
-            <a:srgbClr val="ECEFF1"/>
-          </a:solidFill>
-          <a:ln w="15240">
-            <a:solidFill>
-              <a:srgbClr val="B0BEC5"/>
-            </a:solidFill>
-          </a:ln>
-        </p:spPr>
-        <p:style>
-          <a:lnRef idx="1">
-            <a:schemeClr val="accent1"/>
-          </a:lnRef>
-          <a:fillRef idx="3">
-            <a:schemeClr val="accent1"/>
-          </a:fillRef>
-          <a:effectRef idx="2">
-            <a:schemeClr val="accent1"/>
-          </a:effectRef>
-          <a:fontRef idx="minor">
-            <a:schemeClr val="lt1"/>
-          </a:fontRef>
-        </p:style>
-        <p:txBody>
-          <a:bodyPr rtlCol="0" anchor="ctr" wrap="none"/>
-          <a:lstStyle/>
-          <a:p>
-            <a:pPr algn="ctr"/>
-          </a:p>
-        </p:txBody>
-      </p:sp>
-      <p:sp>
-        <p:nvSpPr>
-          <p:cNvPr id="52" name="Rounded Rectangle 51"/>
-          <p:cNvSpPr/>
-          <p:nvPr/>
-        </p:nvSpPr>
-        <p:spPr>
-          <a:xfrm>
-            <a:off x="246888" y="8138160"/>
-            <a:ext cx="292608" cy="237744"/>
-          </a:xfrm>
-          <a:prstGeom prst="roundRect">
-            <a:avLst>
-              <a:gd name="adj" fmla="val 4000"/>
-            </a:avLst>
-          </a:prstGeom>
-          <a:solidFill>
-            <a:srgbClr val="1565C0"/>
-          </a:solidFill>
-          <a:ln>
-            <a:noFill/>
-          </a:ln>
-        </p:spPr>
-        <p:style>
-          <a:lnRef idx="1">
-            <a:schemeClr val="accent1"/>
-          </a:lnRef>
-          <a:fillRef idx="3">
-            <a:schemeClr val="accent1"/>
-          </a:fillRef>
-          <a:effectRef idx="2">
-            <a:schemeClr val="accent1"/>
-          </a:effectRef>
-          <a:fontRef idx="minor">
-            <a:schemeClr val="lt1"/>
-          </a:fontRef>
-        </p:style>
-        <p:txBody>
-          <a:bodyPr rtlCol="0" anchor="ctr" wrap="none"/>
-          <a:lstStyle/>
-          <a:p>
-            <a:pPr algn="ctr"/>
-          </a:p>
-        </p:txBody>
-      </p:sp>
-      <p:sp>
-        <p:nvSpPr>
-          <p:cNvPr id="53" name="TextBox 52"/>
+              <a:t>action_dim=2</a:t>
+            </a:r>
+          </a:p>
+        </p:txBody>
+      </p:sp>
+      <p:sp>
+        <p:nvSpPr>
+          <p:cNvPr id="52" name="TextBox 51"/>
           <p:cNvSpPr txBox="1"/>
           <p:nvPr/>
         </p:nvSpPr>
         <p:spPr>
           <a:xfrm>
-            <a:off x="585216" y="8138160"/>
-            <a:ext cx="783336" cy="274320"/>
+            <a:off x="99752" y="7939604"/>
+            <a:ext cx="14430894" cy="250806"/>
           </a:xfrm>
           <a:prstGeom prst="rect">
             <a:avLst/>
@@ -5877,886 +5700,12 @@
           <a:p>
             <a:pPr algn="ctr"/>
             <a:r>
-              <a:rPr sz="750" b="0">
-                <a:solidFill>
-                  <a:srgbClr val="1C1C1C"/>
+              <a:rPr sz="800" b="0">
+                <a:solidFill>
+                  <a:srgbClr val="546E7A"/>
                 </a:solidFill>
               </a:rPr>
-              <a:t>Vision</a:t>
-            </a:r>
-          </a:p>
-        </p:txBody>
-      </p:sp>
-      <p:sp>
-        <p:nvSpPr>
-          <p:cNvPr id="54" name="Rounded Rectangle 53"/>
-          <p:cNvSpPr/>
-          <p:nvPr/>
-        </p:nvSpPr>
-        <p:spPr>
-          <a:xfrm>
-            <a:off x="1432560" y="8138160"/>
-            <a:ext cx="292608" cy="237744"/>
-          </a:xfrm>
-          <a:prstGeom prst="roundRect">
-            <a:avLst>
-              <a:gd name="adj" fmla="val 4000"/>
-            </a:avLst>
-          </a:prstGeom>
-          <a:solidFill>
-            <a:srgbClr val="2E7D32"/>
-          </a:solidFill>
-          <a:ln>
-            <a:noFill/>
-          </a:ln>
-        </p:spPr>
-        <p:style>
-          <a:lnRef idx="1">
-            <a:schemeClr val="accent1"/>
-          </a:lnRef>
-          <a:fillRef idx="3">
-            <a:schemeClr val="accent1"/>
-          </a:fillRef>
-          <a:effectRef idx="2">
-            <a:schemeClr val="accent1"/>
-          </a:effectRef>
-          <a:fontRef idx="minor">
-            <a:schemeClr val="lt1"/>
-          </a:fontRef>
-        </p:style>
-        <p:txBody>
-          <a:bodyPr rtlCol="0" anchor="ctr" wrap="none"/>
-          <a:lstStyle/>
-          <a:p>
-            <a:pPr algn="ctr"/>
-          </a:p>
-        </p:txBody>
-      </p:sp>
-      <p:sp>
-        <p:nvSpPr>
-          <p:cNvPr id="55" name="TextBox 54"/>
-          <p:cNvSpPr txBox="1"/>
-          <p:nvPr/>
-        </p:nvSpPr>
-        <p:spPr>
-          <a:xfrm>
-            <a:off x="1770887" y="8138160"/>
-            <a:ext cx="783336" cy="274320"/>
-          </a:xfrm>
-          <a:prstGeom prst="rect">
-            <a:avLst/>
-          </a:prstGeom>
-          <a:noFill/>
-        </p:spPr>
-        <p:txBody>
-          <a:bodyPr wrap="square">
-            <a:spAutoFit/>
-          </a:bodyPr>
-          <a:lstStyle/>
-          <a:p>
-            <a:pPr algn="ctr"/>
-            <a:r>
-              <a:rPr sz="750" b="0">
-                <a:solidFill>
-                  <a:srgbClr val="1C1C1C"/>
-                </a:solidFill>
-              </a:rPr>
-              <a:t>Instruction</a:t>
-            </a:r>
-          </a:p>
-        </p:txBody>
-      </p:sp>
-      <p:sp>
-        <p:nvSpPr>
-          <p:cNvPr id="56" name="Rounded Rectangle 55"/>
-          <p:cNvSpPr/>
-          <p:nvPr/>
-        </p:nvSpPr>
-        <p:spPr>
-          <a:xfrm>
-            <a:off x="2618232" y="8138160"/>
-            <a:ext cx="292608" cy="237744"/>
-          </a:xfrm>
-          <a:prstGeom prst="roundRect">
-            <a:avLst>
-              <a:gd name="adj" fmla="val 4000"/>
-            </a:avLst>
-          </a:prstGeom>
-          <a:solidFill>
-            <a:srgbClr val="E65100"/>
-          </a:solidFill>
-          <a:ln>
-            <a:noFill/>
-          </a:ln>
-        </p:spPr>
-        <p:style>
-          <a:lnRef idx="1">
-            <a:schemeClr val="accent1"/>
-          </a:lnRef>
-          <a:fillRef idx="3">
-            <a:schemeClr val="accent1"/>
-          </a:fillRef>
-          <a:effectRef idx="2">
-            <a:schemeClr val="accent1"/>
-          </a:effectRef>
-          <a:fontRef idx="minor">
-            <a:schemeClr val="lt1"/>
-          </a:fontRef>
-        </p:style>
-        <p:txBody>
-          <a:bodyPr rtlCol="0" anchor="ctr" wrap="none"/>
-          <a:lstStyle/>
-          <a:p>
-            <a:pPr algn="ctr"/>
-          </a:p>
-        </p:txBody>
-      </p:sp>
-      <p:sp>
-        <p:nvSpPr>
-          <p:cNvPr id="57" name="TextBox 56"/>
-          <p:cNvSpPr txBox="1"/>
-          <p:nvPr/>
-        </p:nvSpPr>
-        <p:spPr>
-          <a:xfrm>
-            <a:off x="2956560" y="8138160"/>
-            <a:ext cx="783336" cy="274320"/>
-          </a:xfrm>
-          <a:prstGeom prst="rect">
-            <a:avLst/>
-          </a:prstGeom>
-          <a:noFill/>
-        </p:spPr>
-        <p:txBody>
-          <a:bodyPr wrap="square">
-            <a:spAutoFit/>
-          </a:bodyPr>
-          <a:lstStyle/>
-          <a:p>
-            <a:pPr algn="ctr"/>
-            <a:r>
-              <a:rPr sz="750" b="0">
-                <a:solidFill>
-                  <a:srgbClr val="1C1C1C"/>
-                </a:solidFill>
-              </a:rPr>
-              <a:t>Action Narration</a:t>
-            </a:r>
-          </a:p>
-        </p:txBody>
-      </p:sp>
-      <p:sp>
-        <p:nvSpPr>
-          <p:cNvPr id="58" name="Rounded Rectangle 57"/>
-          <p:cNvSpPr/>
-          <p:nvPr/>
-        </p:nvSpPr>
-        <p:spPr>
-          <a:xfrm>
-            <a:off x="3803903" y="8138160"/>
-            <a:ext cx="292608" cy="237744"/>
-          </a:xfrm>
-          <a:prstGeom prst="roundRect">
-            <a:avLst>
-              <a:gd name="adj" fmla="val 4000"/>
-            </a:avLst>
-          </a:prstGeom>
-          <a:solidFill>
-            <a:srgbClr val="AD1457"/>
-          </a:solidFill>
-          <a:ln>
-            <a:noFill/>
-          </a:ln>
-        </p:spPr>
-        <p:style>
-          <a:lnRef idx="1">
-            <a:schemeClr val="accent1"/>
-          </a:lnRef>
-          <a:fillRef idx="3">
-            <a:schemeClr val="accent1"/>
-          </a:fillRef>
-          <a:effectRef idx="2">
-            <a:schemeClr val="accent1"/>
-          </a:effectRef>
-          <a:fontRef idx="minor">
-            <a:schemeClr val="lt1"/>
-          </a:fontRef>
-        </p:style>
-        <p:txBody>
-          <a:bodyPr rtlCol="0" anchor="ctr" wrap="none"/>
-          <a:lstStyle/>
-          <a:p>
-            <a:pPr algn="ctr"/>
-          </a:p>
-        </p:txBody>
-      </p:sp>
-      <p:sp>
-        <p:nvSpPr>
-          <p:cNvPr id="59" name="TextBox 58"/>
-          <p:cNvSpPr txBox="1"/>
-          <p:nvPr/>
-        </p:nvSpPr>
-        <p:spPr>
-          <a:xfrm>
-            <a:off x="4142231" y="8138160"/>
-            <a:ext cx="783336" cy="274320"/>
-          </a:xfrm>
-          <a:prstGeom prst="rect">
-            <a:avLst/>
-          </a:prstGeom>
-          <a:noFill/>
-        </p:spPr>
-        <p:txBody>
-          <a:bodyPr wrap="square">
-            <a:spAutoFit/>
-          </a:bodyPr>
-          <a:lstStyle/>
-          <a:p>
-            <a:pPr algn="ctr"/>
-            <a:r>
-              <a:rPr sz="750" b="0">
-                <a:solidFill>
-                  <a:srgbClr val="1C1C1C"/>
-                </a:solidFill>
-              </a:rPr>
-              <a:t>Embodied Consequence [NEW]</a:t>
-            </a:r>
-          </a:p>
-        </p:txBody>
-      </p:sp>
-      <p:sp>
-        <p:nvSpPr>
-          <p:cNvPr id="60" name="Rounded Rectangle 59"/>
-          <p:cNvSpPr/>
-          <p:nvPr/>
-        </p:nvSpPr>
-        <p:spPr>
-          <a:xfrm>
-            <a:off x="4989575" y="8138160"/>
-            <a:ext cx="292608" cy="237744"/>
-          </a:xfrm>
-          <a:prstGeom prst="roundRect">
-            <a:avLst>
-              <a:gd name="adj" fmla="val 4000"/>
-            </a:avLst>
-          </a:prstGeom>
-          <a:solidFill>
-            <a:srgbClr val="6A1B9A"/>
-          </a:solidFill>
-          <a:ln>
-            <a:noFill/>
-          </a:ln>
-        </p:spPr>
-        <p:style>
-          <a:lnRef idx="1">
-            <a:schemeClr val="accent1"/>
-          </a:lnRef>
-          <a:fillRef idx="3">
-            <a:schemeClr val="accent1"/>
-          </a:fillRef>
-          <a:effectRef idx="2">
-            <a:schemeClr val="accent1"/>
-          </a:effectRef>
-          <a:fontRef idx="minor">
-            <a:schemeClr val="lt1"/>
-          </a:fontRef>
-        </p:style>
-        <p:txBody>
-          <a:bodyPr rtlCol="0" anchor="ctr" wrap="none"/>
-          <a:lstStyle/>
-          <a:p>
-            <a:pPr algn="ctr"/>
-          </a:p>
-        </p:txBody>
-      </p:sp>
-      <p:sp>
-        <p:nvSpPr>
-          <p:cNvPr id="61" name="TextBox 60"/>
-          <p:cNvSpPr txBox="1"/>
-          <p:nvPr/>
-        </p:nvSpPr>
-        <p:spPr>
-          <a:xfrm>
-            <a:off x="5327904" y="8138160"/>
-            <a:ext cx="783336" cy="274320"/>
-          </a:xfrm>
-          <a:prstGeom prst="rect">
-            <a:avLst/>
-          </a:prstGeom>
-          <a:noFill/>
-        </p:spPr>
-        <p:txBody>
-          <a:bodyPr wrap="square">
-            <a:spAutoFit/>
-          </a:bodyPr>
-          <a:lstStyle/>
-          <a:p>
-            <a:pPr algn="ctr"/>
-            <a:r>
-              <a:rPr sz="750" b="0">
-                <a:solidFill>
-                  <a:srgbClr val="1C1C1C"/>
-                </a:solidFill>
-              </a:rPr>
-              <a:t>History</a:t>
-            </a:r>
-          </a:p>
-        </p:txBody>
-      </p:sp>
-      <p:sp>
-        <p:nvSpPr>
-          <p:cNvPr id="62" name="Rounded Rectangle 61"/>
-          <p:cNvSpPr/>
-          <p:nvPr/>
-        </p:nvSpPr>
-        <p:spPr>
-          <a:xfrm>
-            <a:off x="6175248" y="8138160"/>
-            <a:ext cx="292608" cy="237744"/>
-          </a:xfrm>
-          <a:prstGeom prst="roundRect">
-            <a:avLst>
-              <a:gd name="adj" fmla="val 4000"/>
-            </a:avLst>
-          </a:prstGeom>
-          <a:solidFill>
-            <a:srgbClr val="1565C0"/>
-          </a:solidFill>
-          <a:ln w="25400">
-            <a:solidFill>
-              <a:srgbClr val="A5D6A7"/>
-            </a:solidFill>
-          </a:ln>
-        </p:spPr>
-        <p:style>
-          <a:lnRef idx="1">
-            <a:schemeClr val="accent1"/>
-          </a:lnRef>
-          <a:fillRef idx="3">
-            <a:schemeClr val="accent1"/>
-          </a:fillRef>
-          <a:effectRef idx="2">
-            <a:schemeClr val="accent1"/>
-          </a:effectRef>
-          <a:fontRef idx="minor">
-            <a:schemeClr val="lt1"/>
-          </a:fontRef>
-        </p:style>
-        <p:txBody>
-          <a:bodyPr rtlCol="0" anchor="ctr" wrap="none"/>
-          <a:lstStyle/>
-          <a:p>
-            <a:pPr algn="ctr"/>
-          </a:p>
-        </p:txBody>
-      </p:sp>
-      <p:sp>
-        <p:nvSpPr>
-          <p:cNvPr id="63" name="TextBox 62"/>
-          <p:cNvSpPr txBox="1"/>
-          <p:nvPr/>
-        </p:nvSpPr>
-        <p:spPr>
-          <a:xfrm>
-            <a:off x="6513576" y="8138160"/>
-            <a:ext cx="783336" cy="274320"/>
-          </a:xfrm>
-          <a:prstGeom prst="rect">
-            <a:avLst/>
-          </a:prstGeom>
-          <a:noFill/>
-        </p:spPr>
-        <p:txBody>
-          <a:bodyPr wrap="square">
-            <a:spAutoFit/>
-          </a:bodyPr>
-          <a:lstStyle/>
-          <a:p>
-            <a:pPr algn="ctr"/>
-            <a:r>
-              <a:rPr sz="750" b="0">
-                <a:solidFill>
-                  <a:srgbClr val="1C1C1C"/>
-                </a:solidFill>
-              </a:rPr>
-              <a:t>CLIP ViT ✓ trainable (lr=3e-6)</a:t>
-            </a:r>
-          </a:p>
-        </p:txBody>
-      </p:sp>
-      <p:sp>
-        <p:nvSpPr>
-          <p:cNvPr id="64" name="Rounded Rectangle 63"/>
-          <p:cNvSpPr/>
-          <p:nvPr/>
-        </p:nvSpPr>
-        <p:spPr>
-          <a:xfrm>
-            <a:off x="7360919" y="8138160"/>
-            <a:ext cx="292608" cy="237744"/>
-          </a:xfrm>
-          <a:prstGeom prst="roundRect">
-            <a:avLst>
-              <a:gd name="adj" fmla="val 4000"/>
-            </a:avLst>
-          </a:prstGeom>
-          <a:solidFill>
-            <a:srgbClr val="37474F"/>
-          </a:solidFill>
-          <a:ln w="25400">
-            <a:solidFill>
-              <a:srgbClr val="80DEEA"/>
-            </a:solidFill>
-            <a:prstDash val="dash"/>
-          </a:ln>
-        </p:spPr>
-        <p:style>
-          <a:lnRef idx="1">
-            <a:schemeClr val="accent1"/>
-          </a:lnRef>
-          <a:fillRef idx="3">
-            <a:schemeClr val="accent1"/>
-          </a:fillRef>
-          <a:effectRef idx="2">
-            <a:schemeClr val="accent1"/>
-          </a:effectRef>
-          <a:fontRef idx="minor">
-            <a:schemeClr val="lt1"/>
-          </a:fontRef>
-        </p:style>
-        <p:txBody>
-          <a:bodyPr rtlCol="0" anchor="ctr" wrap="none"/>
-          <a:lstStyle/>
-          <a:p>
-            <a:pPr algn="ctr"/>
-          </a:p>
-        </p:txBody>
-      </p:sp>
-      <p:sp>
-        <p:nvSpPr>
-          <p:cNvPr id="65" name="TextBox 64"/>
-          <p:cNvSpPr txBox="1"/>
-          <p:nvPr/>
-        </p:nvSpPr>
-        <p:spPr>
-          <a:xfrm>
-            <a:off x="7699248" y="8138160"/>
-            <a:ext cx="783336" cy="274320"/>
-          </a:xfrm>
-          <a:prstGeom prst="rect">
-            <a:avLst/>
-          </a:prstGeom>
-          <a:noFill/>
-        </p:spPr>
-        <p:txBody>
-          <a:bodyPr wrap="square">
-            <a:spAutoFit/>
-          </a:bodyPr>
-          <a:lstStyle/>
-          <a:p>
-            <a:pPr algn="ctr"/>
-            <a:r>
-              <a:rPr sz="750" b="0">
-                <a:solidFill>
-                  <a:srgbClr val="1C1C1C"/>
-                </a:solidFill>
-              </a:rPr>
-              <a:t>CLIP Text ❄ FROZEN</a:t>
-            </a:r>
-          </a:p>
-        </p:txBody>
-      </p:sp>
-      <p:sp>
-        <p:nvSpPr>
-          <p:cNvPr id="66" name="Rounded Rectangle 65"/>
-          <p:cNvSpPr/>
-          <p:nvPr/>
-        </p:nvSpPr>
-        <p:spPr>
-          <a:xfrm>
-            <a:off x="8546592" y="8138160"/>
-            <a:ext cx="292608" cy="237744"/>
-          </a:xfrm>
-          <a:prstGeom prst="roundRect">
-            <a:avLst>
-              <a:gd name="adj" fmla="val 4000"/>
-            </a:avLst>
-          </a:prstGeom>
-          <a:solidFill>
-            <a:srgbClr val="4527A0"/>
-          </a:solidFill>
-          <a:ln>
-            <a:noFill/>
-          </a:ln>
-        </p:spPr>
-        <p:style>
-          <a:lnRef idx="1">
-            <a:schemeClr val="accent1"/>
-          </a:lnRef>
-          <a:fillRef idx="3">
-            <a:schemeClr val="accent1"/>
-          </a:fillRef>
-          <a:effectRef idx="2">
-            <a:schemeClr val="accent1"/>
-          </a:effectRef>
-          <a:fontRef idx="minor">
-            <a:schemeClr val="lt1"/>
-          </a:fontRef>
-        </p:style>
-        <p:txBody>
-          <a:bodyPr rtlCol="0" anchor="ctr" wrap="none"/>
-          <a:lstStyle/>
-          <a:p>
-            <a:pPr algn="ctr"/>
-          </a:p>
-        </p:txBody>
-      </p:sp>
-      <p:sp>
-        <p:nvSpPr>
-          <p:cNvPr id="67" name="TextBox 66"/>
-          <p:cNvSpPr txBox="1"/>
-          <p:nvPr/>
-        </p:nvSpPr>
-        <p:spPr>
-          <a:xfrm>
-            <a:off x="8884920" y="8138160"/>
-            <a:ext cx="783336" cy="274320"/>
-          </a:xfrm>
-          <a:prstGeom prst="rect">
-            <a:avLst/>
-          </a:prstGeom>
-          <a:noFill/>
-        </p:spPr>
-        <p:txBody>
-          <a:bodyPr wrap="square">
-            <a:spAutoFit/>
-          </a:bodyPr>
-          <a:lstStyle/>
-          <a:p>
-            <a:pPr algn="ctr"/>
-            <a:r>
-              <a:rPr sz="750" b="0">
-                <a:solidFill>
-                  <a:srgbClr val="1C1C1C"/>
-                </a:solidFill>
-              </a:rPr>
-              <a:t>2L Causal Sub-TF</a:t>
-            </a:r>
-          </a:p>
-        </p:txBody>
-      </p:sp>
-      <p:sp>
-        <p:nvSpPr>
-          <p:cNvPr id="68" name="Rounded Rectangle 67"/>
-          <p:cNvSpPr/>
-          <p:nvPr/>
-        </p:nvSpPr>
-        <p:spPr>
-          <a:xfrm>
-            <a:off x="9732264" y="8138160"/>
-            <a:ext cx="292608" cy="237744"/>
-          </a:xfrm>
-          <a:prstGeom prst="roundRect">
-            <a:avLst>
-              <a:gd name="adj" fmla="val 4000"/>
-            </a:avLst>
-          </a:prstGeom>
-          <a:solidFill>
-            <a:srgbClr val="1A237E"/>
-          </a:solidFill>
-          <a:ln>
-            <a:noFill/>
-          </a:ln>
-        </p:spPr>
-        <p:style>
-          <a:lnRef idx="1">
-            <a:schemeClr val="accent1"/>
-          </a:lnRef>
-          <a:fillRef idx="3">
-            <a:schemeClr val="accent1"/>
-          </a:fillRef>
-          <a:effectRef idx="2">
-            <a:schemeClr val="accent1"/>
-          </a:effectRef>
-          <a:fontRef idx="minor">
-            <a:schemeClr val="lt1"/>
-          </a:fontRef>
-        </p:style>
-        <p:txBody>
-          <a:bodyPr rtlCol="0" anchor="ctr" wrap="none"/>
-          <a:lstStyle/>
-          <a:p>
-            <a:pPr algn="ctr"/>
-          </a:p>
-        </p:txBody>
-      </p:sp>
-      <p:sp>
-        <p:nvSpPr>
-          <p:cNvPr id="69" name="TextBox 68"/>
-          <p:cNvSpPr txBox="1"/>
-          <p:nvPr/>
-        </p:nvSpPr>
-        <p:spPr>
-          <a:xfrm>
-            <a:off x="10070592" y="8138160"/>
-            <a:ext cx="783336" cy="274320"/>
-          </a:xfrm>
-          <a:prstGeom prst="rect">
-            <a:avLst/>
-          </a:prstGeom>
-          <a:noFill/>
-        </p:spPr>
-        <p:txBody>
-          <a:bodyPr wrap="square">
-            <a:spAutoFit/>
-          </a:bodyPr>
-          <a:lstStyle/>
-          <a:p>
-            <a:pPr algn="ctr"/>
-            <a:r>
-              <a:rPr sz="750" b="0">
-                <a:solidFill>
-                  <a:srgbClr val="1C1C1C"/>
-                </a:solidFill>
-              </a:rPr>
-              <a:t>6L Bidir Fusion TF</a:t>
-            </a:r>
-          </a:p>
-        </p:txBody>
-      </p:sp>
-      <p:sp>
-        <p:nvSpPr>
-          <p:cNvPr id="70" name="Rounded Rectangle 69"/>
-          <p:cNvSpPr/>
-          <p:nvPr/>
-        </p:nvSpPr>
-        <p:spPr>
-          <a:xfrm>
-            <a:off x="10917936" y="8138160"/>
-            <a:ext cx="292608" cy="237744"/>
-          </a:xfrm>
-          <a:prstGeom prst="roundRect">
-            <a:avLst>
-              <a:gd name="adj" fmla="val 4000"/>
-            </a:avLst>
-          </a:prstGeom>
-          <a:solidFill>
-            <a:srgbClr val="BF360C"/>
-          </a:solidFill>
-          <a:ln>
-            <a:noFill/>
-          </a:ln>
-        </p:spPr>
-        <p:style>
-          <a:lnRef idx="1">
-            <a:schemeClr val="accent1"/>
-          </a:lnRef>
-          <a:fillRef idx="3">
-            <a:schemeClr val="accent1"/>
-          </a:fillRef>
-          <a:effectRef idx="2">
-            <a:schemeClr val="accent1"/>
-          </a:effectRef>
-          <a:fontRef idx="minor">
-            <a:schemeClr val="lt1"/>
-          </a:fontRef>
-        </p:style>
-        <p:txBody>
-          <a:bodyPr rtlCol="0" anchor="ctr" wrap="none"/>
-          <a:lstStyle/>
-          <a:p>
-            <a:pPr algn="ctr"/>
-          </a:p>
-        </p:txBody>
-      </p:sp>
-      <p:sp>
-        <p:nvSpPr>
-          <p:cNvPr id="71" name="TextBox 70"/>
-          <p:cNvSpPr txBox="1"/>
-          <p:nvPr/>
-        </p:nvSpPr>
-        <p:spPr>
-          <a:xfrm>
-            <a:off x="11256264" y="8138160"/>
-            <a:ext cx="783336" cy="274320"/>
-          </a:xfrm>
-          <a:prstGeom prst="rect">
-            <a:avLst/>
-          </a:prstGeom>
-          <a:noFill/>
-        </p:spPr>
-        <p:txBody>
-          <a:bodyPr wrap="square">
-            <a:spAutoFit/>
-          </a:bodyPr>
-          <a:lstStyle/>
-          <a:p>
-            <a:pPr algn="ctr"/>
-            <a:r>
-              <a:rPr sz="750" b="0">
-                <a:solidFill>
-                  <a:srgbClr val="1C1C1C"/>
-                </a:solidFill>
-              </a:rPr>
-              <a:t>Discrete Head (8-bin×K=4)</a:t>
-            </a:r>
-          </a:p>
-        </p:txBody>
-      </p:sp>
-      <p:sp>
-        <p:nvSpPr>
-          <p:cNvPr id="72" name="Rounded Rectangle 71"/>
-          <p:cNvSpPr/>
-          <p:nvPr/>
-        </p:nvSpPr>
-        <p:spPr>
-          <a:xfrm>
-            <a:off x="12103608" y="8138160"/>
-            <a:ext cx="292608" cy="237744"/>
-          </a:xfrm>
-          <a:prstGeom prst="roundRect">
-            <a:avLst>
-              <a:gd name="adj" fmla="val 4000"/>
-            </a:avLst>
-          </a:prstGeom>
-          <a:solidFill>
-            <a:srgbClr val="1B5E20"/>
-          </a:solidFill>
-          <a:ln>
-            <a:noFill/>
-          </a:ln>
-        </p:spPr>
-        <p:style>
-          <a:lnRef idx="1">
-            <a:schemeClr val="accent1"/>
-          </a:lnRef>
-          <a:fillRef idx="3">
-            <a:schemeClr val="accent1"/>
-          </a:fillRef>
-          <a:effectRef idx="2">
-            <a:schemeClr val="accent1"/>
-          </a:effectRef>
-          <a:fontRef idx="minor">
-            <a:schemeClr val="lt1"/>
-          </a:fontRef>
-        </p:style>
-        <p:txBody>
-          <a:bodyPr rtlCol="0" anchor="ctr" wrap="none"/>
-          <a:lstStyle/>
-          <a:p>
-            <a:pPr algn="ctr"/>
-          </a:p>
-        </p:txBody>
-      </p:sp>
-      <p:sp>
-        <p:nvSpPr>
-          <p:cNvPr id="73" name="TextBox 72"/>
-          <p:cNvSpPr txBox="1"/>
-          <p:nvPr/>
-        </p:nvSpPr>
-        <p:spPr>
-          <a:xfrm>
-            <a:off x="12441936" y="8138160"/>
-            <a:ext cx="783336" cy="274320"/>
-          </a:xfrm>
-          <a:prstGeom prst="rect">
-            <a:avLst/>
-          </a:prstGeom>
-          <a:noFill/>
-        </p:spPr>
-        <p:txBody>
-          <a:bodyPr wrap="square">
-            <a:spAutoFit/>
-          </a:bodyPr>
-          <a:lstStyle/>
-          <a:p>
-            <a:pPr algn="ctr"/>
-            <a:r>
-              <a:rPr sz="750" b="0">
-                <a:solidFill>
-                  <a:srgbClr val="1C1C1C"/>
-                </a:solidFill>
-              </a:rPr>
-              <a:t>Regression Head [Δx,Δy]</a:t>
-            </a:r>
-          </a:p>
-        </p:txBody>
-      </p:sp>
-      <p:sp>
-        <p:nvSpPr>
-          <p:cNvPr id="74" name="Rounded Rectangle 73"/>
-          <p:cNvSpPr/>
-          <p:nvPr/>
-        </p:nvSpPr>
-        <p:spPr>
-          <a:xfrm>
-            <a:off x="13289280" y="8138160"/>
-            <a:ext cx="292608" cy="237744"/>
-          </a:xfrm>
-          <a:prstGeom prst="roundRect">
-            <a:avLst>
-              <a:gd name="adj" fmla="val 4000"/>
-            </a:avLst>
-          </a:prstGeom>
-          <a:solidFill>
-            <a:srgbClr val="F57F17"/>
-          </a:solidFill>
-          <a:ln>
-            <a:noFill/>
-          </a:ln>
-        </p:spPr>
-        <p:style>
-          <a:lnRef idx="1">
-            <a:schemeClr val="accent1"/>
-          </a:lnRef>
-          <a:fillRef idx="3">
-            <a:schemeClr val="accent1"/>
-          </a:fillRef>
-          <a:effectRef idx="2">
-            <a:schemeClr val="accent1"/>
-          </a:effectRef>
-          <a:fontRef idx="minor">
-            <a:schemeClr val="lt1"/>
-          </a:fontRef>
-        </p:style>
-        <p:txBody>
-          <a:bodyPr rtlCol="0" anchor="ctr" wrap="none"/>
-          <a:lstStyle/>
-          <a:p>
-            <a:pPr algn="ctr"/>
-          </a:p>
-        </p:txBody>
-      </p:sp>
-      <p:sp>
-        <p:nvSpPr>
-          <p:cNvPr id="75" name="TextBox 74"/>
-          <p:cNvSpPr txBox="1"/>
-          <p:nvPr/>
-        </p:nvSpPr>
-        <p:spPr>
-          <a:xfrm>
-            <a:off x="13627608" y="8138160"/>
-            <a:ext cx="783336" cy="274320"/>
-          </a:xfrm>
-          <a:prstGeom prst="rect">
-            <a:avLst/>
-          </a:prstGeom>
-          <a:noFill/>
-        </p:spPr>
-        <p:txBody>
-          <a:bodyPr wrap="square">
-            <a:spAutoFit/>
-          </a:bodyPr>
-          <a:lstStyle/>
-          <a:p>
-            <a:pPr algn="ctr"/>
-            <a:r>
-              <a:rPr sz="750" b="0">
-                <a:solidFill>
-                  <a:srgbClr val="1C1C1C"/>
-                </a:solidFill>
-              </a:rPr>
-              <a:t>InfoNCE Loss (λ=0.10)</a:t>
+              <a:t>5-stream closed-loop robot policy  ·  6-layer Bidirectional LLaMA Fusion Transformer  ·  K=4 action chunking  ·  λ_align=0.10</a:t>
             </a:r>
           </a:p>
         </p:txBody>

</xml_diff>

<commit_message>
Add concise input examples to VERA diagram
Each stream box now shows a short concrete example:
  Vision:             "frames t, t-1, t-2"
  Instruction:        "push block to red region"
  Action Narration:   "I pushed the block left"
  Embodied Knowledge: "block moved closer to goal"
  History:            (←,0.12) (←,0.09) (↑,0.04) …

Co-Authored-By: Claude Sonnet 4.6 <noreply@anthropic.com>
</commit_message>
<xml_diff>
--- a/docs/VERA_architecture.pptx
+++ b/docs/VERA_architecture.pptx
@@ -3301,12 +3301,12 @@
           <a:p>
             <a:pPr algn="ctr"/>
             <a:r>
-              <a:rPr sz="800" b="0">
+              <a:rPr sz="750" b="0">
                 <a:solidFill>
                   <a:srgbClr val="FFFFFF"/>
                 </a:solidFill>
               </a:rPr>
-              <a:t>3 RGB Frames · 224×224×3</a:t>
+              <a:t>frames t, t−1, t−2</a:t>
             </a:r>
           </a:p>
         </p:txBody>
@@ -3365,12 +3365,12 @@
           <a:p>
             <a:pPr algn="ctr"/>
             <a:r>
-              <a:rPr sz="800" b="0">
+              <a:rPr sz="750" b="0">
                 <a:solidFill>
                   <a:srgbClr val="FFFFFF"/>
                 </a:solidFill>
               </a:rPr>
-              <a:t>"push block left"</a:t>
+              <a:t>"push block to red region"</a:t>
             </a:r>
           </a:p>
         </p:txBody>
@@ -3429,12 +3429,12 @@
           <a:p>
             <a:pPr algn="ctr"/>
             <a:r>
-              <a:rPr sz="800" b="0">
+              <a:rPr sz="750" b="0">
                 <a:solidFill>
                   <a:srgbClr val="FFFFFF"/>
                 </a:solidFill>
               </a:rPr>
-              <a:t>a_{t−1} text narration</a:t>
+              <a:t>"I pushed the block left"</a:t>
             </a:r>
           </a:p>
         </p:txBody>
@@ -3493,12 +3493,12 @@
           <a:p>
             <a:pPr algn="ctr"/>
             <a:r>
-              <a:rPr sz="800" b="0">
+              <a:rPr sz="750" b="0">
                 <a:solidFill>
                   <a:srgbClr val="FFFFFF"/>
                 </a:solidFill>
               </a:rPr>
-              <a:t>r_{t−1} · Δd_{t−1}</a:t>
+              <a:t>"block moved closer to goal"</a:t>
             </a:r>
           </a:p>
         </p:txBody>
@@ -3557,12 +3557,12 @@
           <a:p>
             <a:pPr algn="ctr"/>
             <a:r>
-              <a:rPr sz="800" b="0">
+              <a:rPr sz="750" b="0">
                 <a:solidFill>
                   <a:srgbClr val="FFFFFF"/>
                 </a:solidFill>
               </a:rPr>
-              <a:t>H=4 (action, reward) pairs</a:t>
+              <a:t>(←,0.12)  (←,0.09)  (↑,0.04)  …</a:t>
             </a:r>
           </a:p>
         </p:txBody>

</xml_diff>